<commit_message>
docs: rebuild week 8-9 evidence and add review report
</commit_message>
<xml_diff>
--- a/docs/slides/Slide_Bao_Cao_Tuan_8_9_DBO_IDBO.pptx
+++ b/docs/slides/Slide_Bao_Cao_Tuan_8_9_DBO_IDBO.pptx
@@ -3109,8 +3109,8 @@
         </p:nvSpPr>
         <p:spPr>
           <a:xfrm>
-            <a:off x="0" y="0"/>
-            <a:ext cx="12191695" cy="6858000"/>
+            <a:off x="9144" y="9144"/>
+            <a:ext cx="12173407" cy="6839712"/>
           </a:xfrm>
           <a:prstGeom prst="rect">
             <a:avLst/>
@@ -3153,8 +3153,8 @@
         </p:nvSpPr>
         <p:spPr>
           <a:xfrm>
-            <a:off x="0" y="0"/>
-            <a:ext cx="12191695" cy="164592"/>
+            <a:off x="9144" y="9144"/>
+            <a:ext cx="12173407" cy="155448"/>
           </a:xfrm>
           <a:prstGeom prst="rect">
             <a:avLst/>
@@ -3655,7 +3655,7 @@
                 <a:ea typeface="Calibri"/>
                 <a:cs typeface="Calibri"/>
               </a:rPr>
-              <a:t>Thời gian báo cáo: Tuần 8–9 (Tháng 10/2026) · 193/193 Unit Tests PASS · CSDL 15.929 món sạch</a:t>
+              <a:t>Thời gian báo cáo: Tuần 8–9 (Tháng 10/2026) · 195/195 Unit Tests PASS · CSDL 15.929 món sạch</a:t>
             </a:r>
           </a:p>
         </p:txBody>
@@ -4275,7 +4275,7 @@
                           <a:ea typeface="Calibri"/>
                           <a:cs typeface="Calibri"/>
                         </a:rPr>
-                        <a:t>Đạt 100% mục tiêu năng lượng &amp; đa lượng</a:t>
+                        <a:t>Đánh giá kỹ thuật theo năng lượng &amp; đa lượng</a:t>
                       </a:r>
                     </a:p>
                   </a:txBody>
@@ -4477,7 +4477,7 @@
                           <a:ea typeface="Calibri"/>
                           <a:cs typeface="Calibri"/>
                         </a:rPr>
-                        <a:t>Đường &lt;= 25g (thực tế 21.2g) · An toàn</a:t>
+                        <a:t>Chưa kết luận đường: dataset không có trường total sugar</a:t>
                       </a:r>
                     </a:p>
                   </a:txBody>
@@ -4679,7 +4679,7 @@
                           <a:ea typeface="Calibri"/>
                           <a:cs typeface="Calibri"/>
                         </a:rPr>
-                        <a:t>Natri &lt;= 1500mg (thực tế 1340mg) · Đạt AHA</a:t>
+                        <a:t>Cần đánh giá tỷ lệ ngày đạt giới hạn natri 1500mg</a:t>
                       </a:r>
                     </a:p>
                   </a:txBody>
@@ -4881,7 +4881,7 @@
                           <a:ea typeface="Calibri"/>
                           <a:cs typeface="Calibri"/>
                         </a:rPr>
-                        <a:t>Đạt 100% mục tiêu năng lượng &amp; đa lượng</a:t>
+                        <a:t>Đánh giá kỹ thuật theo năng lượng &amp; đa lượng</a:t>
                       </a:r>
                     </a:p>
                   </a:txBody>
@@ -5083,7 +5083,7 @@
                           <a:ea typeface="Calibri"/>
                           <a:cs typeface="Calibri"/>
                         </a:rPr>
-                        <a:t>Đường &lt;= 25g (thực tế 21.2g) · An toàn</a:t>
+                        <a:t>Chưa kết luận đường: dataset không có trường total sugar</a:t>
                       </a:r>
                     </a:p>
                   </a:txBody>
@@ -5285,7 +5285,7 @@
                           <a:ea typeface="Calibri"/>
                           <a:cs typeface="Calibri"/>
                         </a:rPr>
-                        <a:t>Natri &lt;= 1500mg (thực tế 1340mg) · Đạt AHA</a:t>
+                        <a:t>Cần đánh giá tỷ lệ ngày đạt giới hạn natri 1500mg</a:t>
                       </a:r>
                     </a:p>
                   </a:txBody>
@@ -6177,7 +6177,7 @@
         <p:spPr>
           <a:xfrm>
             <a:off x="502920" y="1234440"/>
-            <a:ext cx="5440680" cy="3436218"/>
+            <a:ext cx="5440680" cy="3504236"/>
           </a:xfrm>
           <a:prstGeom prst="rect">
             <a:avLst/>
@@ -6270,8 +6270,8 @@
                 <a:cs typeface="Calibri"/>
               </a:rPr>
               <a:t>W9-F1: Heatmap tỷ lệ đáp ứng dinh dưỡng 7 ngày (Profile P1)
-• Toàn bộ 7 ngày đều dao động quanh mức chuẩn 95% – 105% nhu cầu khuyến nghị.
-• Không có ngày nào bị thiếu hụt năng lượng (&lt;85%) hoặc dư thừa quá mức (&gt;120%).</a:t>
+• Năng lượng nhìn chung bám mục tiêu, nhưng chất xơ biến động giữa các ngày.
+• Natri vượt giới hạn ở một số ngày; đây là hạn chế cần xử lý bằng ràng buộc trực tiếp.</a:t>
             </a:r>
           </a:p>
         </p:txBody>
@@ -6293,7 +6293,7 @@
         <p:spPr>
           <a:xfrm>
             <a:off x="6245352" y="1234440"/>
-            <a:ext cx="5440680" cy="3740467"/>
+            <a:ext cx="5440680" cy="3660352"/>
           </a:xfrm>
           <a:prstGeom prst="rect">
             <a:avLst/>
@@ -6386,8 +6386,8 @@
                 <a:cs typeface="Calibri"/>
               </a:rPr>
               <a:t>W9-F2: Đối chuẩn Mean Fitness &amp; Độ lệch Calo trên 3 hồ sơ
-• Mean Fitness duy trì ở mức cao: P1 (90.8), P2 (85.5), P3 (91.0).
-• Lệch Calo dưới 4% trên toàn bộ các hồ sơ, khẳng định tính thích ứng phổ quát.</a:t>
+• Mean Fitness theo CSV: P1 (90.68), P2 (79.27), P3 (88.09).
+• Sai lệch calo: P1 2.37%, P2 5.59%, P3 1.84%; P2 cần tiếp tục cải thiện.</a:t>
             </a:r>
           </a:p>
         </p:txBody>
@@ -6735,7 +6735,7 @@
         <p:spPr>
           <a:xfrm>
             <a:off x="502920" y="1234440"/>
-            <a:ext cx="4937760" cy="4937760"/>
+            <a:ext cx="5120640" cy="4651073"/>
           </a:xfrm>
           <a:prstGeom prst="rect">
             <a:avLst/>
@@ -8129,7 +8129,7 @@
                 <a:ea typeface="Calibri"/>
                 <a:cs typeface="Calibri"/>
               </a:rPr>
-              <a:t>Đảm Bảo Chất Lượng Phần Mềm (193/193 Tests PASS) &amp; Phân Công</a:t>
+              <a:t>Đảm Bảo Chất Lượng Phần Mềm (195/195 Tests PASS) &amp; Phân Công</a:t>
             </a:r>
           </a:p>
         </p:txBody>

</xml_diff>

<commit_message>
docs(slides): synchronize slide deck with 202 tests pass, academic transparency on diabetes, and culinary slot integration
</commit_message>
<xml_diff>
--- a/docs/slides/Slide_Bao_Cao_Tuan_8_9_DBO_IDBO.pptx
+++ b/docs/slides/Slide_Bao_Cao_Tuan_8_9_DBO_IDBO.pptx
@@ -3655,7 +3655,7 @@
                 <a:ea typeface="Calibri"/>
                 <a:cs typeface="Calibri"/>
               </a:rPr>
-              <a:t>Thời gian báo cáo: Tuần 8–9 (Tháng 10/2026) · 195/195 Unit Tests PASS · CSDL 15.929 món sạch</a:t>
+              <a:t>Thời gian báo cáo: Tuần 8–9 (Tháng 10/2026) · 202/202 Unit Tests PASS · CSDL 15.929 món tích hợp</a:t>
             </a:r>
           </a:p>
         </p:txBody>
@@ -6177,7 +6177,7 @@
         <p:spPr>
           <a:xfrm>
             <a:off x="502920" y="1234440"/>
-            <a:ext cx="5440680" cy="3504236"/>
+            <a:ext cx="5440680" cy="3436218"/>
           </a:xfrm>
           <a:prstGeom prst="rect">
             <a:avLst/>
@@ -6293,7 +6293,7 @@
         <p:spPr>
           <a:xfrm>
             <a:off x="6245352" y="1234440"/>
-            <a:ext cx="5440680" cy="3660352"/>
+            <a:ext cx="5440680" cy="3740467"/>
           </a:xfrm>
           <a:prstGeom prst="rect">
             <a:avLst/>
@@ -6735,7 +6735,7 @@
         <p:spPr>
           <a:xfrm>
             <a:off x="502920" y="1234440"/>
-            <a:ext cx="5120640" cy="4651073"/>
+            <a:ext cx="4937760" cy="4937760"/>
           </a:xfrm>
           <a:prstGeom prst="rect">
             <a:avLst/>
@@ -8129,7 +8129,7 @@
                 <a:ea typeface="Calibri"/>
                 <a:cs typeface="Calibri"/>
               </a:rPr>
-              <a:t>Đảm Bảo Chất Lượng Phần Mềm (195/195 Tests PASS) &amp; Phân Công</a:t>
+              <a:t>Đảm Bảo Chất Lượng Phần Mềm (202/202 Tests PASS) &amp; Phân Công</a:t>
             </a:r>
           </a:p>
         </p:txBody>
@@ -8307,7 +8307,7 @@
                 <a:ea typeface="Calibri"/>
                 <a:cs typeface="Calibri"/>
               </a:rPr>
-              <a:t>HỆ THỐNG KIỂM THỬ TỰ ĐỘNG: 193/193 TESTS PASS (100%)</a:t>
+              <a:t>HỆ THỐNG KIỂM THỬ TỰ ĐỘNG: 202/202 TESTS PASS (100%)</a:t>
             </a:r>
           </a:p>
         </p:txBody>
@@ -8366,7 +8366,7 @@
         </p:nvGraphicFramePr>
         <p:xfrm>
           <a:off x="640080" y="1828800"/>
-          <a:ext cx="5166359" cy="3712464"/>
+          <a:ext cx="5166359" cy="4041648"/>
         </p:xfrm>
         <a:graphic>
           <a:graphicData uri="http://schemas.openxmlformats.org/drawingml/2006/table">
@@ -8421,7 +8421,7 @@
                           <a:ea typeface="Calibri"/>
                           <a:cs typeface="Calibri"/>
                         </a:rPr>
-                        <a:t>Số test cases</a:t>
+                        <a:t>Số test</a:t>
                       </a:r>
                     </a:p>
                   </a:txBody>
@@ -8482,7 +8482,7 @@
                   </a:tcPr>
                 </a:tc>
               </a:tr>
-              <a:tr h="475488">
+              <a:tr h="457200">
                 <a:tc>
                   <a:txBody>
                     <a:bodyPr/>
@@ -8523,7 +8523,7 @@
                           <a:ea typeface="Calibri"/>
                           <a:cs typeface="Calibri"/>
                         </a:rPr>
-                        <a:t>12 tests</a:t>
+                        <a:t>5 tests</a:t>
                       </a:r>
                     </a:p>
                   </a:txBody>
@@ -8584,7 +8584,7 @@
                   </a:tcPr>
                 </a:tc>
               </a:tr>
-              <a:tr h="475488">
+              <a:tr h="457200">
                 <a:tc>
                   <a:txBody>
                     <a:bodyPr/>
@@ -8625,7 +8625,7 @@
                           <a:ea typeface="Calibri"/>
                           <a:cs typeface="Calibri"/>
                         </a:rPr>
-                        <a:t>16 tests</a:t>
+                        <a:t>13 tests</a:t>
                       </a:r>
                     </a:p>
                   </a:txBody>
@@ -8650,7 +8650,7 @@
                           <a:ea typeface="Calibri"/>
                           <a:cs typeface="Calibri"/>
                         </a:rPr>
-                        <a:t>Lọc Pool theo bữa, loại trừ dị ứng, giải mã z</a:t>
+                        <a:t>Lọc Pool theo bữa, loại trừ dị ứng, linear probing z</a:t>
                       </a:r>
                     </a:p>
                   </a:txBody>
@@ -8686,7 +8686,7 @@
                   </a:tcPr>
                 </a:tc>
               </a:tr>
-              <a:tr h="475488">
+              <a:tr h="457200">
                 <a:tc>
                   <a:txBody>
                     <a:bodyPr/>
@@ -8727,7 +8727,7 @@
                           <a:ea typeface="Calibri"/>
                           <a:cs typeface="Calibri"/>
                         </a:rPr>
-                        <a:t>14 tests</a:t>
+                        <a:t>17 tests</a:t>
                       </a:r>
                     </a:p>
                   </a:txBody>
@@ -8788,7 +8788,7 @@
                   </a:tcPr>
                 </a:tc>
               </a:tr>
-              <a:tr h="475488">
+              <a:tr h="457200">
                 <a:tc>
                   <a:txBody>
                     <a:bodyPr/>
@@ -8890,7 +8890,7 @@
                   </a:tcPr>
                 </a:tc>
               </a:tr>
-              <a:tr h="475488">
+              <a:tr h="457200">
                 <a:tc>
                   <a:txBody>
                     <a:bodyPr/>
@@ -8906,7 +8906,7 @@
                           <a:ea typeface="Calibri"/>
                           <a:cs typeface="Calibri"/>
                         </a:rPr>
-                        <a:t>test_experiment_week8.py</a:t>
+                        <a:t>test_constraints.py</a:t>
                       </a:r>
                     </a:p>
                   </a:txBody>
@@ -8931,7 +8931,7 @@
                           <a:ea typeface="Calibri"/>
                           <a:cs typeface="Calibri"/>
                         </a:rPr>
-                        <a:t>8 tests</a:t>
+                        <a:t>7 tests</a:t>
                       </a:r>
                     </a:p>
                   </a:txBody>
@@ -8956,7 +8956,7 @@
                           <a:ea typeface="Calibri"/>
                           <a:cs typeface="Calibri"/>
                         </a:rPr>
-                        <a:t>Pipeline chạy benchmark 10 runs, CSV/PNG Tuần 8</a:t>
+                        <a:t>Ràng buộc năng lượng, macro, natri tăng huyết áp</a:t>
                       </a:r>
                     </a:p>
                   </a:txBody>
@@ -8992,7 +8992,7 @@
                   </a:tcPr>
                 </a:tc>
               </a:tr>
-              <a:tr h="475488">
+              <a:tr h="457200">
                 <a:tc>
                   <a:txBody>
                     <a:bodyPr/>
@@ -9008,7 +9008,7 @@
                           <a:ea typeface="Calibri"/>
                           <a:cs typeface="Calibri"/>
                         </a:rPr>
-                        <a:t>test_experiment_week9.py</a:t>
+                        <a:t>test_data_integrity.py</a:t>
                       </a:r>
                     </a:p>
                   </a:txBody>
@@ -9033,7 +9033,7 @@
                           <a:ea typeface="Calibri"/>
                           <a:cs typeface="Calibri"/>
                         </a:rPr>
-                        <a:t>12 tests</a:t>
+                        <a:t>5 tests</a:t>
                       </a:r>
                     </a:p>
                   </a:txBody>
@@ -9058,7 +9058,7 @@
                           <a:ea typeface="Calibri"/>
                           <a:cs typeface="Calibri"/>
                         </a:rPr>
-                        <a:t>Pipeline 7 ngày, kiểm soát Đường &amp; Natri P1/P2/P3</a:t>
+                        <a:t>Schema dữ liệu chuẩn, chặn bột trứng/nguyên liệu thô</a:t>
                       </a:r>
                     </a:p>
                   </a:txBody>
@@ -9094,7 +9094,7 @@
                   </a:tcPr>
                 </a:tc>
               </a:tr>
-              <a:tr h="475488">
+              <a:tr h="457200">
                 <a:tc>
                   <a:txBody>
                     <a:bodyPr/>
@@ -9110,7 +9110,7 @@
                           <a:ea typeface="Calibri"/>
                           <a:cs typeface="Calibri"/>
                         </a:rPr>
-                        <a:t>Module kế thừa Tuần 1–7</a:t>
+                        <a:t>test_culinary_realism.py</a:t>
                       </a:r>
                     </a:p>
                   </a:txBody>
@@ -9135,7 +9135,7 @@
                           <a:ea typeface="Calibri"/>
                           <a:cs typeface="Calibri"/>
                         </a:rPr>
-                        <a:t>121 tests</a:t>
+                        <a:t>2 tests</a:t>
                       </a:r>
                     </a:p>
                   </a:txBody>
@@ -9160,7 +9160,7 @@
                           <a:ea typeface="Calibri"/>
                           <a:cs typeface="Calibri"/>
                         </a:rPr>
-                        <a:t>BMR/TDEE, DBO, IDBO, Objective, Constraints</a:t>
+                        <a:t>Cơ cấu mâm cơm theo Slot (Tinh bột + Đạm + Rau)</a:t>
                       </a:r>
                     </a:p>
                   </a:txBody>
@@ -9196,6 +9196,108 @@
                   </a:tcPr>
                 </a:tc>
               </a:tr>
+              <a:tr h="457200">
+                <a:tc>
+                  <a:txBody>
+                    <a:bodyPr/>
+                    <a:lstStyle/>
+                    <a:p>
+                      <a:pPr algn="l"/>
+                      <a:r>
+                        <a:rPr sz="900" b="1" i="0">
+                          <a:solidFill>
+                            <a:srgbClr val="1E2430"/>
+                          </a:solidFill>
+                          <a:latin typeface="Calibri"/>
+                          <a:ea typeface="Calibri"/>
+                          <a:cs typeface="Calibri"/>
+                        </a:rPr>
+                        <a:t>Module thuật toán &amp; W1–7</a:t>
+                      </a:r>
+                    </a:p>
+                  </a:txBody>
+                  <a:tcPr marL="73152" marR="73152" marT="27432" marB="27432" anchor="ctr">
+                    <a:solidFill>
+                      <a:srgbClr val="FFFFFF"/>
+                    </a:solidFill>
+                  </a:tcPr>
+                </a:tc>
+                <a:tc>
+                  <a:txBody>
+                    <a:bodyPr/>
+                    <a:lstStyle/>
+                    <a:p>
+                      <a:pPr algn="ctr"/>
+                      <a:r>
+                        <a:rPr sz="900" b="0" i="0">
+                          <a:solidFill>
+                            <a:srgbClr val="1E2430"/>
+                          </a:solidFill>
+                          <a:latin typeface="Calibri"/>
+                          <a:ea typeface="Calibri"/>
+                          <a:cs typeface="Calibri"/>
+                        </a:rPr>
+                        <a:t>143 tests</a:t>
+                      </a:r>
+                    </a:p>
+                  </a:txBody>
+                  <a:tcPr marL="73152" marR="73152" marT="27432" marB="27432" anchor="ctr">
+                    <a:solidFill>
+                      <a:srgbClr val="FFFFFF"/>
+                    </a:solidFill>
+                  </a:tcPr>
+                </a:tc>
+                <a:tc>
+                  <a:txBody>
+                    <a:bodyPr/>
+                    <a:lstStyle/>
+                    <a:p>
+                      <a:pPr algn="l"/>
+                      <a:r>
+                        <a:rPr sz="900" b="0" i="0">
+                          <a:solidFill>
+                            <a:srgbClr val="1E2430"/>
+                          </a:solidFill>
+                          <a:latin typeface="Calibri"/>
+                          <a:ea typeface="Calibri"/>
+                          <a:cs typeface="Calibri"/>
+                        </a:rPr>
+                        <a:t>BMR/TDEE, DBO, IDBO, Benchmark CEC, Objective</a:t>
+                      </a:r>
+                    </a:p>
+                  </a:txBody>
+                  <a:tcPr marL="73152" marR="73152" marT="27432" marB="27432" anchor="ctr">
+                    <a:solidFill>
+                      <a:srgbClr val="FFFFFF"/>
+                    </a:solidFill>
+                  </a:tcPr>
+                </a:tc>
+                <a:tc>
+                  <a:txBody>
+                    <a:bodyPr/>
+                    <a:lstStyle/>
+                    <a:p>
+                      <a:pPr algn="ctr"/>
+                      <a:r>
+                        <a:rPr sz="900" b="1" i="0">
+                          <a:solidFill>
+                            <a:srgbClr val="217A4B"/>
+                          </a:solidFill>
+                          <a:latin typeface="Calibri"/>
+                          <a:ea typeface="Calibri"/>
+                          <a:cs typeface="Calibri"/>
+                        </a:rPr>
+                        <a:t>PASS 100%</a:t>
+                      </a:r>
+                    </a:p>
+                  </a:txBody>
+                  <a:tcPr marL="73152" marR="73152" marT="27432" marB="27432" anchor="ctr">
+                    <a:solidFill>
+                      <a:srgbClr val="FFFFFF"/>
+                    </a:solidFill>
+                  </a:tcPr>
+                </a:tc>
+              </a:tr>
             </a:tbl>
           </a:graphicData>
         </a:graphic>
@@ -10644,7 +10746,7 @@
                 <a:ea typeface="Calibri"/>
                 <a:cs typeface="Calibri"/>
               </a:rPr>
-              <a:t>3. TÍNH NĂNG ĐỔI MÓN THÔNG MINH</a:t>
+              <a:t>3. TÍNH NĂNG ĐỔI MÓN &amp; VAI TRÒ ẨM THỰC</a:t>
             </a:r>
           </a:p>
         </p:txBody>
@@ -10688,7 +10790,7 @@
                 <a:ea typeface="Calibri"/>
                 <a:cs typeface="Calibri"/>
               </a:rPr>
-              <a:t>Smart Meal Swap Mechanism</a:t>
+              <a:t>Smart Meal Swap &amp; Culinary Slots</a:t>
             </a:r>
           </a:p>
         </p:txBody>
@@ -10776,9 +10878,9 @@
                 <a:ea typeface="Calibri"/>
                 <a:cs typeface="Calibri"/>
               </a:rPr>
-              <a:t>• Khi người dùng không thích 1 món, hệ thống gợi ý món thay thế cùng nhóm dinh dưỡng.
+              <a:t>• Gợi ý món thay thế theo đúng vai trò món (Cơm/Bún, Món đạm, Rau/Canh), loại bỏ nguyên liệu thô.
 • Chạy lại Tầng 2 (Inner Solver) trong 0.2s để tái cân bằng năng lượng mà không phá vỡ cấu trúc thực đơn tuần.
-• Kiểm tra tính hợp lệ tức thì trước khi lưu.</a:t>
+• Đảm bảo thực đơn sinh ra vừa khít calo vừa hợp khẩu vị thực tế.</a:t>
             </a:r>
           </a:p>
         </p:txBody>
@@ -12178,8 +12280,8 @@
                 <a:cs typeface="Calibri"/>
               </a:rPr>
               <a:t>• Cơ chế phạt lặp món Diversity Penalty cửa sổ trượt 2 ngày (&gt;= 80% độc nhất).
-• Hỗ trợ 3 hồ sơ bệnh lý: P1 (Chuẩn), P2 (Tiểu đường), P3 (Tăng huyết áp).
-• Siết chặt ràng buộc lâm sàng: Đường &lt;= 25g/ngày, Natri &lt;= 1500mg/ngày.
+• Hỗ trợ 3 hồ sơ bệnh lý: P1 (Chuẩn), P2 (Kiểm soát Carbs - ĐTĐ), P3 (Tăng huyết áp).
+• Ràng buộc thực nghiệm: Giảm tải Carbs P2, kiểm soát Natri &lt;= 1500mg/ngày P3.
 • Bộ sinh đa phương án UX (Option A/B/C với các seed độc lập).</a:t>
             </a:r>
           </a:p>
@@ -21486,8 +21588,9 @@
 • Mức vận động: LIGHT (Vận động nhẹ).
 • Mục tiêu: Giảm cân nhẹ (LOSE_WEIGHT, TDEE - 500).
 • Nhu cầu Năng lượng: 1.179,6 kcal/ngày.
-• RÀNG BUỘC NGHIÊM NGẶT: Đường (Sugar) &lt;= 25.0g.
-• Phạt vi phạm đường: w_sugar = 3.0 × max(0, sugar - 25).
+• ĐỊNH HƯỚNG DINH DƯỠNG: Giảm Carbs &amp; kiểm soát calo chặt chẽ.
+• Minh bạch học thuật: CSDL chưa có cột đường tổng (sugar_g);
+  hệ thống dùng proxy carbs 15% để thử nghiệm kỹ thuật, chưa tuyên bố y tế.
 • Cơ cấu bữa: Sáng (2), Trưa (2), Tối (2), Phụ (1).</a:t>
             </a:r>
           </a:p>

</xml_diff>

<commit_message>
docs(slides): apply fix_build_pptx_week8_9 patch with 202 tests pass and synchronized PDF
</commit_message>
<xml_diff>
--- a/docs/slides/Slide_Bao_Cao_Tuan_8_9_DBO_IDBO.pptx
+++ b/docs/slides/Slide_Bao_Cao_Tuan_8_9_DBO_IDBO.pptx
@@ -3448,7 +3448,7 @@
                 <a:ea typeface="Calibri"/>
                 <a:cs typeface="Calibri"/>
               </a:rPr>
-              <a:t>Tự chọn món tự do từ 15.929 thực phẩm · Phạt lặp Diversity Penalty · Kiểm soát Đường &amp; Natri</a:t>
+              <a:t>Tự chọn món tự do từ 15.929 thực phẩm · Phạt lặp Diversity Penalty · Đánh giá Carbohydrate &amp; Kiểm soát Natri</a:t>
             </a:r>
           </a:p>
         </p:txBody>
@@ -4073,7 +4073,7 @@
                           <a:ea typeface="Calibri"/>
                           <a:cs typeface="Calibri"/>
                         </a:rPr>
-                        <a:t>Đánh giá an toàn y tế</a:t>
+                        <a:t>Diễn giải kỹ thuật &amp; giới hạn</a:t>
                       </a:r>
                     </a:p>
                   </a:txBody>
@@ -5741,7 +5741,7 @@
                 <a:ea typeface="Calibri"/>
                 <a:cs typeface="Calibri"/>
               </a:rPr>
-              <a:t>Tuân thủ ràng buộc bệnh lý:</a:t>
+              <a:t>Giới hạn dữ liệu &amp; diễn giải:</a:t>
             </a:r>
           </a:p>
         </p:txBody>
@@ -5829,7 +5829,7 @@
                 <a:ea typeface="Calibri"/>
                 <a:cs typeface="Calibri"/>
               </a:rPr>
-              <a:t>Trên hồ sơ P2 (Tiểu đường), hàm lượng đường được giữ an toàn dưới 25g. Trên hồ sơ P3 (Tăng HA), mức Natri kiểm soát tốt dưới ngưỡng 1500mg AHA.</a:t>
+              <a:t>P2 chưa có dữ liệu total sugar: chỉ đánh giá năng lượng, Carbs và đa lượng; proxy 15% Carbs không dùng để kết luận an toàn. P3 kiểm tra Natri trực tiếp theo ngưỡng cấu hình 1.500mg/ngày và cần báo cáo tỷ lệ ngày đạt ngưỡng.</a:t>
             </a:r>
           </a:p>
         </p:txBody>
@@ -5917,7 +5917,7 @@
                 <a:ea typeface="Calibri"/>
                 <a:cs typeface="Calibri"/>
               </a:rPr>
-              <a:t>Bảng tổng hợp kết quả thực nghiệm 7 ngày trên ba hồ sơ bệnh lý</a:t>
+              <a:t>Bảng tổng hợp kết quả kỹ thuật 7 ngày trên ba hồ sơ dinh dưỡng mô phỏng</a:t>
             </a:r>
           </a:p>
         </p:txBody>
@@ -7718,7 +7718,7 @@
                           <a:ea typeface="Calibri"/>
                           <a:cs typeface="Calibri"/>
                         </a:rPr>
-                        <a:t>Đánh giá trải nghiệm</a:t>
+                        <a:t>Đặc điểm đo được</a:t>
                       </a:r>
                     </a:p>
                   </a:txBody>
@@ -7743,7 +7743,7 @@
                           <a:ea typeface="Calibri"/>
                           <a:cs typeface="Calibri"/>
                         </a:rPr>
-                        <a:t>Cân bằng tối ưu, vị thanh</a:t>
+                        <a:t>Seed 9001 · Độc nhất 100%</a:t>
                       </a:r>
                     </a:p>
                   </a:txBody>
@@ -7768,7 +7768,7 @@
                           <a:ea typeface="Calibri"/>
                           <a:cs typeface="Calibri"/>
                         </a:rPr>
-                        <a:t>Giàu chất xơ, đạm thực vật</a:t>
+                        <a:t>Seed 9002 · Độc nhất 85.7%</a:t>
                       </a:r>
                     </a:p>
                   </a:txBody>
@@ -7793,7 +7793,7 @@
                           <a:ea typeface="Calibri"/>
                           <a:cs typeface="Calibri"/>
                         </a:rPr>
-                        <a:t>Đậm đà, năng lượng chuẩn</a:t>
+                        <a:t>Seed 9003 · Lệch calo thấp nhất</a:t>
                       </a:r>
                     </a:p>
                   </a:txBody>
@@ -7847,7 +7847,7 @@
                 <a:ea typeface="Calibri"/>
                 <a:cs typeface="Calibri"/>
               </a:rPr>
-              <a:t>• Ý nghĩa trải nghiệm người dùng: Không áp đặt 1 thực đơn duy nhất. Hệ thống cung cấp 3 lựa chọn với phong cách ẩm thực khác biệt, người dùng có toàn quyền chọn phương án ưa thích.</a:t>
+              <a:t>• Ba phương án được sinh từ seed độc lập và so sánh bằng fitness, sai lệch calo, độ đa dạng. Hệ thống chưa đánh giá khẩu vị hoặc phong cách ẩm thực.</a:t>
             </a:r>
           </a:p>
         </p:txBody>
@@ -8366,7 +8366,7 @@
         </p:nvGraphicFramePr>
         <p:xfrm>
           <a:off x="640080" y="1828800"/>
-          <a:ext cx="5166359" cy="4041648"/>
+          <a:ext cx="5166359" cy="5138928"/>
         </p:xfrm>
         <a:graphic>
           <a:graphicData uri="http://schemas.openxmlformats.org/drawingml/2006/table">
@@ -8421,7 +8421,7 @@
                           <a:ea typeface="Calibri"/>
                           <a:cs typeface="Calibri"/>
                         </a:rPr>
-                        <a:t>Số test</a:t>
+                        <a:t>Số test cases</a:t>
                       </a:r>
                     </a:p>
                   </a:txBody>
@@ -8482,7 +8482,7 @@
                   </a:tcPr>
                 </a:tc>
               </a:tr>
-              <a:tr h="457200">
+              <a:tr h="475488">
                 <a:tc>
                   <a:txBody>
                     <a:bodyPr/>
@@ -8523,7 +8523,7 @@
                           <a:ea typeface="Calibri"/>
                           <a:cs typeface="Calibri"/>
                         </a:rPr>
-                        <a:t>5 tests</a:t>
+                        <a:t>12 tests</a:t>
                       </a:r>
                     </a:p>
                   </a:txBody>
@@ -8584,7 +8584,7 @@
                   </a:tcPr>
                 </a:tc>
               </a:tr>
-              <a:tr h="457200">
+              <a:tr h="475488">
                 <a:tc>
                   <a:txBody>
                     <a:bodyPr/>
@@ -8625,7 +8625,7 @@
                           <a:ea typeface="Calibri"/>
                           <a:cs typeface="Calibri"/>
                         </a:rPr>
-                        <a:t>13 tests</a:t>
+                        <a:t>16 tests</a:t>
                       </a:r>
                     </a:p>
                   </a:txBody>
@@ -8650,7 +8650,7 @@
                           <a:ea typeface="Calibri"/>
                           <a:cs typeface="Calibri"/>
                         </a:rPr>
-                        <a:t>Lọc Pool theo bữa, loại trừ dị ứng, linear probing z</a:t>
+                        <a:t>Lọc Pool theo bữa, loại trừ dị ứng, giải mã z</a:t>
                       </a:r>
                     </a:p>
                   </a:txBody>
@@ -8686,7 +8686,7 @@
                   </a:tcPr>
                 </a:tc>
               </a:tr>
-              <a:tr h="457200">
+              <a:tr h="475488">
                 <a:tc>
                   <a:txBody>
                     <a:bodyPr/>
@@ -8727,7 +8727,7 @@
                           <a:ea typeface="Calibri"/>
                           <a:cs typeface="Calibri"/>
                         </a:rPr>
-                        <a:t>17 tests</a:t>
+                        <a:t>14 tests</a:t>
                       </a:r>
                     </a:p>
                   </a:txBody>
@@ -8788,7 +8788,7 @@
                   </a:tcPr>
                 </a:tc>
               </a:tr>
-              <a:tr h="457200">
+              <a:tr h="475488">
                 <a:tc>
                   <a:txBody>
                     <a:bodyPr/>
@@ -8890,7 +8890,415 @@
                   </a:tcPr>
                 </a:tc>
               </a:tr>
-              <a:tr h="457200">
+              <a:tr h="475488">
+                <a:tc>
+                  <a:txBody>
+                    <a:bodyPr/>
+                    <a:lstStyle/>
+                    <a:p>
+                      <a:pPr algn="l"/>
+                      <a:r>
+                        <a:rPr sz="900" b="1" i="0">
+                          <a:solidFill>
+                            <a:srgbClr val="1E2430"/>
+                          </a:solidFill>
+                          <a:latin typeface="Calibri"/>
+                          <a:ea typeface="Calibri"/>
+                          <a:cs typeface="Calibri"/>
+                        </a:rPr>
+                        <a:t>test_experiment_week8.py</a:t>
+                      </a:r>
+                    </a:p>
+                  </a:txBody>
+                  <a:tcPr marL="73152" marR="73152" marT="27432" marB="27432" anchor="ctr">
+                    <a:solidFill>
+                      <a:srgbClr val="F5F7FB"/>
+                    </a:solidFill>
+                  </a:tcPr>
+                </a:tc>
+                <a:tc>
+                  <a:txBody>
+                    <a:bodyPr/>
+                    <a:lstStyle/>
+                    <a:p>
+                      <a:pPr algn="ctr"/>
+                      <a:r>
+                        <a:rPr sz="900" b="0" i="0">
+                          <a:solidFill>
+                            <a:srgbClr val="1E2430"/>
+                          </a:solidFill>
+                          <a:latin typeface="Calibri"/>
+                          <a:ea typeface="Calibri"/>
+                          <a:cs typeface="Calibri"/>
+                        </a:rPr>
+                        <a:t>8 tests</a:t>
+                      </a:r>
+                    </a:p>
+                  </a:txBody>
+                  <a:tcPr marL="73152" marR="73152" marT="27432" marB="27432" anchor="ctr">
+                    <a:solidFill>
+                      <a:srgbClr val="F5F7FB"/>
+                    </a:solidFill>
+                  </a:tcPr>
+                </a:tc>
+                <a:tc>
+                  <a:txBody>
+                    <a:bodyPr/>
+                    <a:lstStyle/>
+                    <a:p>
+                      <a:pPr algn="l"/>
+                      <a:r>
+                        <a:rPr sz="900" b="0" i="0">
+                          <a:solidFill>
+                            <a:srgbClr val="1E2430"/>
+                          </a:solidFill>
+                          <a:latin typeface="Calibri"/>
+                          <a:ea typeface="Calibri"/>
+                          <a:cs typeface="Calibri"/>
+                        </a:rPr>
+                        <a:t>Pipeline chạy benchmark 10 runs, CSV/PNG Tuần 8</a:t>
+                      </a:r>
+                    </a:p>
+                  </a:txBody>
+                  <a:tcPr marL="73152" marR="73152" marT="27432" marB="27432" anchor="ctr">
+                    <a:solidFill>
+                      <a:srgbClr val="F5F7FB"/>
+                    </a:solidFill>
+                  </a:tcPr>
+                </a:tc>
+                <a:tc>
+                  <a:txBody>
+                    <a:bodyPr/>
+                    <a:lstStyle/>
+                    <a:p>
+                      <a:pPr algn="ctr"/>
+                      <a:r>
+                        <a:rPr sz="900" b="1" i="0">
+                          <a:solidFill>
+                            <a:srgbClr val="217A4B"/>
+                          </a:solidFill>
+                          <a:latin typeface="Calibri"/>
+                          <a:ea typeface="Calibri"/>
+                          <a:cs typeface="Calibri"/>
+                        </a:rPr>
+                        <a:t>PASS 100%</a:t>
+                      </a:r>
+                    </a:p>
+                  </a:txBody>
+                  <a:tcPr marL="73152" marR="73152" marT="27432" marB="27432" anchor="ctr">
+                    <a:solidFill>
+                      <a:srgbClr val="F5F7FB"/>
+                    </a:solidFill>
+                  </a:tcPr>
+                </a:tc>
+              </a:tr>
+              <a:tr h="475488">
+                <a:tc>
+                  <a:txBody>
+                    <a:bodyPr/>
+                    <a:lstStyle/>
+                    <a:p>
+                      <a:pPr algn="l"/>
+                      <a:r>
+                        <a:rPr sz="900" b="1" i="0">
+                          <a:solidFill>
+                            <a:srgbClr val="1E2430"/>
+                          </a:solidFill>
+                          <a:latin typeface="Calibri"/>
+                          <a:ea typeface="Calibri"/>
+                          <a:cs typeface="Calibri"/>
+                        </a:rPr>
+                        <a:t>test_experiment_week9.py</a:t>
+                      </a:r>
+                    </a:p>
+                  </a:txBody>
+                  <a:tcPr marL="73152" marR="73152" marT="27432" marB="27432" anchor="ctr">
+                    <a:solidFill>
+                      <a:srgbClr val="FFFFFF"/>
+                    </a:solidFill>
+                  </a:tcPr>
+                </a:tc>
+                <a:tc>
+                  <a:txBody>
+                    <a:bodyPr/>
+                    <a:lstStyle/>
+                    <a:p>
+                      <a:pPr algn="ctr"/>
+                      <a:r>
+                        <a:rPr sz="900" b="0" i="0">
+                          <a:solidFill>
+                            <a:srgbClr val="1E2430"/>
+                          </a:solidFill>
+                          <a:latin typeface="Calibri"/>
+                          <a:ea typeface="Calibri"/>
+                          <a:cs typeface="Calibri"/>
+                        </a:rPr>
+                        <a:t>12 tests</a:t>
+                      </a:r>
+                    </a:p>
+                  </a:txBody>
+                  <a:tcPr marL="73152" marR="73152" marT="27432" marB="27432" anchor="ctr">
+                    <a:solidFill>
+                      <a:srgbClr val="FFFFFF"/>
+                    </a:solidFill>
+                  </a:tcPr>
+                </a:tc>
+                <a:tc>
+                  <a:txBody>
+                    <a:bodyPr/>
+                    <a:lstStyle/>
+                    <a:p>
+                      <a:pPr algn="l"/>
+                      <a:r>
+                        <a:rPr sz="900" b="0" i="0">
+                          <a:solidFill>
+                            <a:srgbClr val="1E2430"/>
+                          </a:solidFill>
+                          <a:latin typeface="Calibri"/>
+                          <a:ea typeface="Calibri"/>
+                          <a:cs typeface="Calibri"/>
+                        </a:rPr>
+                        <a:t>Pipeline 7 ngày, Carbs proxy minh bạch &amp; Natri P1/P2/P3</a:t>
+                      </a:r>
+                    </a:p>
+                  </a:txBody>
+                  <a:tcPr marL="73152" marR="73152" marT="27432" marB="27432" anchor="ctr">
+                    <a:solidFill>
+                      <a:srgbClr val="FFFFFF"/>
+                    </a:solidFill>
+                  </a:tcPr>
+                </a:tc>
+                <a:tc>
+                  <a:txBody>
+                    <a:bodyPr/>
+                    <a:lstStyle/>
+                    <a:p>
+                      <a:pPr algn="ctr"/>
+                      <a:r>
+                        <a:rPr sz="900" b="1" i="0">
+                          <a:solidFill>
+                            <a:srgbClr val="217A4B"/>
+                          </a:solidFill>
+                          <a:latin typeface="Calibri"/>
+                          <a:ea typeface="Calibri"/>
+                          <a:cs typeface="Calibri"/>
+                        </a:rPr>
+                        <a:t>PASS 100%</a:t>
+                      </a:r>
+                    </a:p>
+                  </a:txBody>
+                  <a:tcPr marL="73152" marR="73152" marT="27432" marB="27432" anchor="ctr">
+                    <a:solidFill>
+                      <a:srgbClr val="FFFFFF"/>
+                    </a:solidFill>
+                  </a:tcPr>
+                </a:tc>
+              </a:tr>
+              <a:tr h="475488">
+                <a:tc>
+                  <a:txBody>
+                    <a:bodyPr/>
+                    <a:lstStyle/>
+                    <a:p>
+                      <a:pPr algn="l"/>
+                      <a:r>
+                        <a:rPr sz="900" b="1" i="0">
+                          <a:solidFill>
+                            <a:srgbClr val="1E2430"/>
+                          </a:solidFill>
+                          <a:latin typeface="Calibri"/>
+                          <a:ea typeface="Calibri"/>
+                          <a:cs typeface="Calibri"/>
+                        </a:rPr>
+                        <a:t>test_data_integrity.py</a:t>
+                      </a:r>
+                    </a:p>
+                  </a:txBody>
+                  <a:tcPr marL="73152" marR="73152" marT="27432" marB="27432" anchor="ctr">
+                    <a:solidFill>
+                      <a:srgbClr val="F5F7FB"/>
+                    </a:solidFill>
+                  </a:tcPr>
+                </a:tc>
+                <a:tc>
+                  <a:txBody>
+                    <a:bodyPr/>
+                    <a:lstStyle/>
+                    <a:p>
+                      <a:pPr algn="ctr"/>
+                      <a:r>
+                        <a:rPr sz="900" b="0" i="0">
+                          <a:solidFill>
+                            <a:srgbClr val="1E2430"/>
+                          </a:solidFill>
+                          <a:latin typeface="Calibri"/>
+                          <a:ea typeface="Calibri"/>
+                          <a:cs typeface="Calibri"/>
+                        </a:rPr>
+                        <a:t>5 tests</a:t>
+                      </a:r>
+                    </a:p>
+                  </a:txBody>
+                  <a:tcPr marL="73152" marR="73152" marT="27432" marB="27432" anchor="ctr">
+                    <a:solidFill>
+                      <a:srgbClr val="F5F7FB"/>
+                    </a:solidFill>
+                  </a:tcPr>
+                </a:tc>
+                <a:tc>
+                  <a:txBody>
+                    <a:bodyPr/>
+                    <a:lstStyle/>
+                    <a:p>
+                      <a:pPr algn="l"/>
+                      <a:r>
+                        <a:rPr sz="900" b="0" i="0">
+                          <a:solidFill>
+                            <a:srgbClr val="1E2430"/>
+                          </a:solidFill>
+                          <a:latin typeface="Calibri"/>
+                          <a:ea typeface="Calibri"/>
+                          <a:cs typeface="Calibri"/>
+                        </a:rPr>
+                        <a:t>Schema dữ liệu; chặn nguyên liệu thô không phù hợp</a:t>
+                      </a:r>
+                    </a:p>
+                  </a:txBody>
+                  <a:tcPr marL="73152" marR="73152" marT="27432" marB="27432" anchor="ctr">
+                    <a:solidFill>
+                      <a:srgbClr val="F5F7FB"/>
+                    </a:solidFill>
+                  </a:tcPr>
+                </a:tc>
+                <a:tc>
+                  <a:txBody>
+                    <a:bodyPr/>
+                    <a:lstStyle/>
+                    <a:p>
+                      <a:pPr algn="ctr"/>
+                      <a:r>
+                        <a:rPr sz="900" b="1" i="0">
+                          <a:solidFill>
+                            <a:srgbClr val="217A4B"/>
+                          </a:solidFill>
+                          <a:latin typeface="Calibri"/>
+                          <a:ea typeface="Calibri"/>
+                          <a:cs typeface="Calibri"/>
+                        </a:rPr>
+                        <a:t>PASS 100%</a:t>
+                      </a:r>
+                    </a:p>
+                  </a:txBody>
+                  <a:tcPr marL="73152" marR="73152" marT="27432" marB="27432" anchor="ctr">
+                    <a:solidFill>
+                      <a:srgbClr val="F5F7FB"/>
+                    </a:solidFill>
+                  </a:tcPr>
+                </a:tc>
+              </a:tr>
+              <a:tr h="475488">
+                <a:tc>
+                  <a:txBody>
+                    <a:bodyPr/>
+                    <a:lstStyle/>
+                    <a:p>
+                      <a:pPr algn="l"/>
+                      <a:r>
+                        <a:rPr sz="900" b="1" i="0">
+                          <a:solidFill>
+                            <a:srgbClr val="1E2430"/>
+                          </a:solidFill>
+                          <a:latin typeface="Calibri"/>
+                          <a:ea typeface="Calibri"/>
+                          <a:cs typeface="Calibri"/>
+                        </a:rPr>
+                        <a:t>test_culinary_realism.py</a:t>
+                      </a:r>
+                    </a:p>
+                  </a:txBody>
+                  <a:tcPr marL="73152" marR="73152" marT="27432" marB="27432" anchor="ctr">
+                    <a:solidFill>
+                      <a:srgbClr val="FFFFFF"/>
+                    </a:solidFill>
+                  </a:tcPr>
+                </a:tc>
+                <a:tc>
+                  <a:txBody>
+                    <a:bodyPr/>
+                    <a:lstStyle/>
+                    <a:p>
+                      <a:pPr algn="ctr"/>
+                      <a:r>
+                        <a:rPr sz="900" b="0" i="0">
+                          <a:solidFill>
+                            <a:srgbClr val="1E2430"/>
+                          </a:solidFill>
+                          <a:latin typeface="Calibri"/>
+                          <a:ea typeface="Calibri"/>
+                          <a:cs typeface="Calibri"/>
+                        </a:rPr>
+                        <a:t>2 tests</a:t>
+                      </a:r>
+                    </a:p>
+                  </a:txBody>
+                  <a:tcPr marL="73152" marR="73152" marT="27432" marB="27432" anchor="ctr">
+                    <a:solidFill>
+                      <a:srgbClr val="FFFFFF"/>
+                    </a:solidFill>
+                  </a:tcPr>
+                </a:tc>
+                <a:tc>
+                  <a:txBody>
+                    <a:bodyPr/>
+                    <a:lstStyle/>
+                    <a:p>
+                      <a:pPr algn="l"/>
+                      <a:r>
+                        <a:rPr sz="900" b="0" i="0">
+                          <a:solidFill>
+                            <a:srgbClr val="1E2430"/>
+                          </a:solidFill>
+                          <a:latin typeface="Calibri"/>
+                          <a:ea typeface="Calibri"/>
+                          <a:cs typeface="Calibri"/>
+                        </a:rPr>
+                        <a:t>Kiểm tra cơ cấu món theo Culinary Slots</a:t>
+                      </a:r>
+                    </a:p>
+                  </a:txBody>
+                  <a:tcPr marL="73152" marR="73152" marT="27432" marB="27432" anchor="ctr">
+                    <a:solidFill>
+                      <a:srgbClr val="FFFFFF"/>
+                    </a:solidFill>
+                  </a:tcPr>
+                </a:tc>
+                <a:tc>
+                  <a:txBody>
+                    <a:bodyPr/>
+                    <a:lstStyle/>
+                    <a:p>
+                      <a:pPr algn="ctr"/>
+                      <a:r>
+                        <a:rPr sz="900" b="1" i="0">
+                          <a:solidFill>
+                            <a:srgbClr val="217A4B"/>
+                          </a:solidFill>
+                          <a:latin typeface="Calibri"/>
+                          <a:ea typeface="Calibri"/>
+                          <a:cs typeface="Calibri"/>
+                        </a:rPr>
+                        <a:t>PASS 100%</a:t>
+                      </a:r>
+                    </a:p>
+                  </a:txBody>
+                  <a:tcPr marL="73152" marR="73152" marT="27432" marB="27432" anchor="ctr">
+                    <a:solidFill>
+                      <a:srgbClr val="FFFFFF"/>
+                    </a:solidFill>
+                  </a:tcPr>
+                </a:tc>
+              </a:tr>
+              <a:tr h="475488">
                 <a:tc>
                   <a:txBody>
                     <a:bodyPr/>
@@ -8956,7 +9364,7 @@
                           <a:ea typeface="Calibri"/>
                           <a:cs typeface="Calibri"/>
                         </a:rPr>
-                        <a:t>Ràng buộc năng lượng, macro, natri tăng huyết áp</a:t>
+                        <a:t>Bổ sung ràng buộc Natri cho profile tăng huyết áp</a:t>
                       </a:r>
                     </a:p>
                   </a:txBody>
@@ -8992,7 +9400,7 @@
                   </a:tcPr>
                 </a:tc>
               </a:tr>
-              <a:tr h="457200">
+              <a:tr h="475488">
                 <a:tc>
                   <a:txBody>
                     <a:bodyPr/>
@@ -9008,7 +9416,7 @@
                           <a:ea typeface="Calibri"/>
                           <a:cs typeface="Calibri"/>
                         </a:rPr>
-                        <a:t>test_data_integrity.py</a:t>
+                        <a:t>Module kế thừa Tuần 1–7</a:t>
                       </a:r>
                     </a:p>
                   </a:txBody>
@@ -9033,7 +9441,7 @@
                           <a:ea typeface="Calibri"/>
                           <a:cs typeface="Calibri"/>
                         </a:rPr>
-                        <a:t>5 tests</a:t>
+                        <a:t>116 tests</a:t>
                       </a:r>
                     </a:p>
                   </a:txBody>
@@ -9058,211 +9466,7 @@
                           <a:ea typeface="Calibri"/>
                           <a:cs typeface="Calibri"/>
                         </a:rPr>
-                        <a:t>Schema dữ liệu chuẩn, chặn bột trứng/nguyên liệu thô</a:t>
-                      </a:r>
-                    </a:p>
-                  </a:txBody>
-                  <a:tcPr marL="73152" marR="73152" marT="27432" marB="27432" anchor="ctr">
-                    <a:solidFill>
-                      <a:srgbClr val="FFFFFF"/>
-                    </a:solidFill>
-                  </a:tcPr>
-                </a:tc>
-                <a:tc>
-                  <a:txBody>
-                    <a:bodyPr/>
-                    <a:lstStyle/>
-                    <a:p>
-                      <a:pPr algn="ctr"/>
-                      <a:r>
-                        <a:rPr sz="900" b="1" i="0">
-                          <a:solidFill>
-                            <a:srgbClr val="217A4B"/>
-                          </a:solidFill>
-                          <a:latin typeface="Calibri"/>
-                          <a:ea typeface="Calibri"/>
-                          <a:cs typeface="Calibri"/>
-                        </a:rPr>
-                        <a:t>PASS 100%</a:t>
-                      </a:r>
-                    </a:p>
-                  </a:txBody>
-                  <a:tcPr marL="73152" marR="73152" marT="27432" marB="27432" anchor="ctr">
-                    <a:solidFill>
-                      <a:srgbClr val="FFFFFF"/>
-                    </a:solidFill>
-                  </a:tcPr>
-                </a:tc>
-              </a:tr>
-              <a:tr h="457200">
-                <a:tc>
-                  <a:txBody>
-                    <a:bodyPr/>
-                    <a:lstStyle/>
-                    <a:p>
-                      <a:pPr algn="l"/>
-                      <a:r>
-                        <a:rPr sz="900" b="1" i="0">
-                          <a:solidFill>
-                            <a:srgbClr val="1E2430"/>
-                          </a:solidFill>
-                          <a:latin typeface="Calibri"/>
-                          <a:ea typeface="Calibri"/>
-                          <a:cs typeface="Calibri"/>
-                        </a:rPr>
-                        <a:t>test_culinary_realism.py</a:t>
-                      </a:r>
-                    </a:p>
-                  </a:txBody>
-                  <a:tcPr marL="73152" marR="73152" marT="27432" marB="27432" anchor="ctr">
-                    <a:solidFill>
-                      <a:srgbClr val="F5F7FB"/>
-                    </a:solidFill>
-                  </a:tcPr>
-                </a:tc>
-                <a:tc>
-                  <a:txBody>
-                    <a:bodyPr/>
-                    <a:lstStyle/>
-                    <a:p>
-                      <a:pPr algn="ctr"/>
-                      <a:r>
-                        <a:rPr sz="900" b="0" i="0">
-                          <a:solidFill>
-                            <a:srgbClr val="1E2430"/>
-                          </a:solidFill>
-                          <a:latin typeface="Calibri"/>
-                          <a:ea typeface="Calibri"/>
-                          <a:cs typeface="Calibri"/>
-                        </a:rPr>
-                        <a:t>2 tests</a:t>
-                      </a:r>
-                    </a:p>
-                  </a:txBody>
-                  <a:tcPr marL="73152" marR="73152" marT="27432" marB="27432" anchor="ctr">
-                    <a:solidFill>
-                      <a:srgbClr val="F5F7FB"/>
-                    </a:solidFill>
-                  </a:tcPr>
-                </a:tc>
-                <a:tc>
-                  <a:txBody>
-                    <a:bodyPr/>
-                    <a:lstStyle/>
-                    <a:p>
-                      <a:pPr algn="l"/>
-                      <a:r>
-                        <a:rPr sz="900" b="0" i="0">
-                          <a:solidFill>
-                            <a:srgbClr val="1E2430"/>
-                          </a:solidFill>
-                          <a:latin typeface="Calibri"/>
-                          <a:ea typeface="Calibri"/>
-                          <a:cs typeface="Calibri"/>
-                        </a:rPr>
-                        <a:t>Cơ cấu mâm cơm theo Slot (Tinh bột + Đạm + Rau)</a:t>
-                      </a:r>
-                    </a:p>
-                  </a:txBody>
-                  <a:tcPr marL="73152" marR="73152" marT="27432" marB="27432" anchor="ctr">
-                    <a:solidFill>
-                      <a:srgbClr val="F5F7FB"/>
-                    </a:solidFill>
-                  </a:tcPr>
-                </a:tc>
-                <a:tc>
-                  <a:txBody>
-                    <a:bodyPr/>
-                    <a:lstStyle/>
-                    <a:p>
-                      <a:pPr algn="ctr"/>
-                      <a:r>
-                        <a:rPr sz="900" b="1" i="0">
-                          <a:solidFill>
-                            <a:srgbClr val="217A4B"/>
-                          </a:solidFill>
-                          <a:latin typeface="Calibri"/>
-                          <a:ea typeface="Calibri"/>
-                          <a:cs typeface="Calibri"/>
-                        </a:rPr>
-                        <a:t>PASS 100%</a:t>
-                      </a:r>
-                    </a:p>
-                  </a:txBody>
-                  <a:tcPr marL="73152" marR="73152" marT="27432" marB="27432" anchor="ctr">
-                    <a:solidFill>
-                      <a:srgbClr val="F5F7FB"/>
-                    </a:solidFill>
-                  </a:tcPr>
-                </a:tc>
-              </a:tr>
-              <a:tr h="457200">
-                <a:tc>
-                  <a:txBody>
-                    <a:bodyPr/>
-                    <a:lstStyle/>
-                    <a:p>
-                      <a:pPr algn="l"/>
-                      <a:r>
-                        <a:rPr sz="900" b="1" i="0">
-                          <a:solidFill>
-                            <a:srgbClr val="1E2430"/>
-                          </a:solidFill>
-                          <a:latin typeface="Calibri"/>
-                          <a:ea typeface="Calibri"/>
-                          <a:cs typeface="Calibri"/>
-                        </a:rPr>
-                        <a:t>Module thuật toán &amp; W1–7</a:t>
-                      </a:r>
-                    </a:p>
-                  </a:txBody>
-                  <a:tcPr marL="73152" marR="73152" marT="27432" marB="27432" anchor="ctr">
-                    <a:solidFill>
-                      <a:srgbClr val="FFFFFF"/>
-                    </a:solidFill>
-                  </a:tcPr>
-                </a:tc>
-                <a:tc>
-                  <a:txBody>
-                    <a:bodyPr/>
-                    <a:lstStyle/>
-                    <a:p>
-                      <a:pPr algn="ctr"/>
-                      <a:r>
-                        <a:rPr sz="900" b="0" i="0">
-                          <a:solidFill>
-                            <a:srgbClr val="1E2430"/>
-                          </a:solidFill>
-                          <a:latin typeface="Calibri"/>
-                          <a:ea typeface="Calibri"/>
-                          <a:cs typeface="Calibri"/>
-                        </a:rPr>
-                        <a:t>143 tests</a:t>
-                      </a:r>
-                    </a:p>
-                  </a:txBody>
-                  <a:tcPr marL="73152" marR="73152" marT="27432" marB="27432" anchor="ctr">
-                    <a:solidFill>
-                      <a:srgbClr val="FFFFFF"/>
-                    </a:solidFill>
-                  </a:tcPr>
-                </a:tc>
-                <a:tc>
-                  <a:txBody>
-                    <a:bodyPr/>
-                    <a:lstStyle/>
-                    <a:p>
-                      <a:pPr algn="l"/>
-                      <a:r>
-                        <a:rPr sz="900" b="0" i="0">
-                          <a:solidFill>
-                            <a:srgbClr val="1E2430"/>
-                          </a:solidFill>
-                          <a:latin typeface="Calibri"/>
-                          <a:ea typeface="Calibri"/>
-                          <a:cs typeface="Calibri"/>
-                        </a:rPr>
-                        <a:t>BMR/TDEE, DBO, IDBO, Benchmark CEC, Objective</a:t>
+                        <a:t>BMR/TDEE, DBO, IDBO, Objective, Benchmarks CEC</a:t>
                       </a:r>
                     </a:p>
                   </a:txBody>
@@ -9836,7 +10040,7 @@
                 <a:ea typeface="Calibri"/>
                 <a:cs typeface="Calibri"/>
               </a:rPr>
-              <a:t>Kết quả kiểm thử tự động 193/193 tests PASS và phân công trách nhiệm thành viên</a:t>
+              <a:t>Kết quả kiểm thử tự động 202/202 tests PASS và phân công trách nhiệm thành viên</a:t>
             </a:r>
           </a:p>
         </p:txBody>
@@ -10343,7 +10547,7 @@
               <a:t>• Đóng gói Two-Tier Solver &amp; 7-Day Planner thành dịch vụ API chuẩn hóa.
 • Endpoint /api/menu/generate: Tiếp nhận UserProfile, sinh 3 options A/B/C.
 • Endpoint /api/menu/swap: Cho phép đổi 1 món ăn cụ thể và tự động cân chỉnh lại gram các món còn lại.
-• Phản hồi nhanh dưới 1.5 giây/ngày.</a:t>
+• Mục tiêu sau tối ưu: hướng tới dưới 1.5 giây/ngày bằng cache, warm start, thu gọn pool và xử lý song song.</a:t>
             </a:r>
           </a:p>
         </p:txBody>
@@ -10746,7 +10950,7 @@
                 <a:ea typeface="Calibri"/>
                 <a:cs typeface="Calibri"/>
               </a:rPr>
-              <a:t>3. TÍNH NĂNG ĐỔI MÓN &amp; VAI TRÒ ẨM THỰC</a:t>
+              <a:t>3. ĐỔI MÓN &amp; VAI TRÒ ẨM THỰC</a:t>
             </a:r>
           </a:p>
         </p:txBody>
@@ -10878,9 +11082,9 @@
                 <a:ea typeface="Calibri"/>
                 <a:cs typeface="Calibri"/>
               </a:rPr>
-              <a:t>• Gợi ý món thay thế theo đúng vai trò món (Cơm/Bún, Món đạm, Rau/Canh), loại bỏ nguyên liệu thô.
-• Chạy lại Tầng 2 (Inner Solver) trong 0.2s để tái cân bằng năng lượng mà không phá vỡ cấu trúc thực đơn tuần.
-• Đảm bảo thực đơn sinh ra vừa khít calo vừa hợp khẩu vị thực tế.</a:t>
+              <a:t>• Bổ sung DishRole: tinh bột, đạm, rau, canh, món phụ và nguyên liệu.
+• Chặn nguyên liệu thô hoặc khẩu phần phi thực tế khỏi vị trí món ăn trực tiếp.
+• Khi đổi món, chỉ chọn ứng viên cùng vai trò rồi chạy lại Inner Solver và kiểm tra ràng buộc.</a:t>
             </a:r>
           </a:p>
         </p:txBody>
@@ -12191,7 +12395,7 @@
                 <a:ea typeface="Calibri"/>
                 <a:cs typeface="Calibri"/>
               </a:rPr>
-              <a:t>Diversity Penalty &amp; Clinical Constraints</a:t>
+              <a:t>Diversity Penalty &amp; Profile-Specific Nutrition Constraints</a:t>
             </a:r>
           </a:p>
         </p:txBody>
@@ -12280,8 +12484,8 @@
                 <a:cs typeface="Calibri"/>
               </a:rPr>
               <a:t>• Cơ chế phạt lặp món Diversity Penalty cửa sổ trượt 2 ngày (&gt;= 80% độc nhất).
-• Hỗ trợ 3 hồ sơ bệnh lý: P1 (Chuẩn), P2 (Kiểm soát Carbs - ĐTĐ), P3 (Tăng huyết áp).
-• Ràng buộc thực nghiệm: Giảm tải Carbs P2, kiểm soát Natri &lt;= 1500mg/ngày P3.
+• Hỗ trợ 3 hồ sơ dinh dưỡng mô phỏng: P1 (Chuẩn), P2 (giảm tải Carbs), P3 (kiểm soát Natri).
+• Ràng buộc thực nghiệm: Giảm tải Carbs cho P2; Natri &lt;= 1500mg/ngày cho P3.
 • Bộ sinh đa phương án UX (Option A/B/C với các seed độc lập).</a:t>
             </a:r>
           </a:p>
@@ -16440,7 +16644,7 @@
                 <a:ea typeface="Calibri"/>
                 <a:cs typeface="Calibri"/>
               </a:rPr>
-              <a:t>100% các lần chạy đều thỏa mãn chuẩn dinh dưỡng</a:t>
+              <a:t>100% lượt chạy không ghi nhận vi phạm trong tập ràng buộc kỹ thuật tuần 8</a:t>
             </a:r>
           </a:p>
         </p:txBody>
@@ -16662,7 +16866,7 @@
                 <a:ea typeface="Calibri"/>
                 <a:cs typeface="Calibri"/>
               </a:rPr>
-              <a:t>Hoàn toàn khả thi cho tích hợp hệ thống Web/API</a:t>
+              <a:t>Có tiềm năng tích hợp Web/API sau khi tối ưu thêm hiệu năng</a:t>
             </a:r>
           </a:p>
         </p:txBody>
@@ -17554,7 +17758,7 @@
                 <a:ea typeface="Calibri"/>
                 <a:cs typeface="Calibri"/>
               </a:rPr>
-              <a:t>2. Độ hội tụ ổn định: Mean Fitness đạt 98.2148 với độ lệch chuẩn nhỏ (Std = 1.0663). Cả 20 lượt chạy (10 DBO + 10 IDBO) đều hội tụ về vùng nghiệm hợp lệ (0 vi phạm ràng buộc).</a:t>
+              <a:t>2. Độ hội tụ ổn định: Mean Fitness đạt 98.2148 với độ lệch chuẩn nhỏ (Std = 1.0663). Cả 20 lượt chạy không ghi nhận vi phạm trong tập ràng buộc kỹ thuật của benchmark tuần 8.</a:t>
             </a:r>
           </a:p>
         </p:txBody>
@@ -17598,7 +17802,7 @@
                 <a:ea typeface="Calibri"/>
                 <a:cs typeface="Calibri"/>
               </a:rPr>
-              <a:t>3. Đánh giá chi phí tính toán: Thuật toán cần đánh giá 210 lần tầng Outer và trung bình ~54.800 lần tầng Inner. Thời gian thực thi 7.60s – 8.25s hoàn toàn khả thi trong thực tế ứng dụng hỗ trợ người dùng.</a:t>
+              <a:t>3. Đánh giá chi phí tính toán: Thuật toán cần đánh giá 210 lần tầng Outer và trung bình ~54.800 lần tầng Inner. Thời gian 7.60s – 8.25s cho thấy cần tiếp tục tối ưu, cache hoặc xử lý nền trước khi tích hợp Web/API thời gian thực.</a:t>
             </a:r>
           </a:p>
         </p:txBody>
@@ -18039,8 +18243,8 @@
                 <a:cs typeface="Calibri"/>
               </a:rPr>
               <a:t>W8-F1: Đường cong hội tụ tầng ngoài (Outer Iterations 1–25)
-• IDBO và DBO đều chạy tốt, tăng nhanh từ thế hệ 1 (Fitness ~75) lên trên 97 chỉ sau 8 vòng lặp.
-• Quần thể duy trì ổn định quanh mức 98.2 điểm cho đến hết 25 thế hệ.</a:t>
+• Trong cấu hình 25 vòng lặp, DBO và IDBO cho đường hội tụ và chất lượng nghiệm gần như giống nhau.
+• Cần đối chiếu telemetry perturbation/restart và thử nghiệm dài hơn để đánh giá đóng góp riêng của IDBO.</a:t>
             </a:r>
           </a:p>
         </p:txBody>
@@ -18156,7 +18360,7 @@
               </a:rPr>
               <a:t>W8-F2: Biểu đồ hộp (Boxplot) phân phối Best Fitness qua 10 runs
 • Trung vị (Median) đạt 98.4 điểm, khoảng biến thiên hẹp [96.3, 99.5].
-• Không có ngoại lai (Outliers) xấu; cả 2 thuật toán đều không bị rơi vào nghiệm cục bộ kém.</a:t>
+• Không quan sát thấy outlier thấp trong 10 seed; kết quả chưa đủ để loại trừ nguy cơ nghiệm cục bộ ở cấu hình khác.</a:t>
             </a:r>
           </a:p>
         </p:txBody>
@@ -18438,7 +18642,7 @@
                 <a:ea typeface="Calibri"/>
                 <a:cs typeface="Calibri"/>
               </a:rPr>
-              <a:t>Cân Đối Dinh Dưỡng &amp; Thực Đơn Đề Xuất Thực Tế (W8-F3 &amp; 5g Portions)</a:t>
+              <a:t>Cân Đối Dinh Dưỡng &amp; Minh Họa Nghiệm Tối Ưu Kỹ Thuật (W8-F3 &amp; 5g Portions)</a:t>
             </a:r>
           </a:p>
         </p:txBody>
@@ -19719,7 +19923,7 @@
                 <a:cs typeface="Calibri"/>
               </a:rPr>
               <a:t>• Đạt chuẩn khẩu phần: Hàm round_portions(x, step=5) loại bỏ hoàn toàn số lẻ thập phân.
-• Dinh dưỡng chi tiết: Protein 122.8g (chuẩn 124.6g) | Carbs 312.4g (chuẩn 311.5g) | Fat 82.1g (chuẩn 83.1g).</a:t>
+• Dinh dưỡng: Protein 122.8g | Carbs 312.4g | Fat 82.1g. Nghiệm chưa áp dụng DishRole và serving bounds theo nhóm; một số tổ hợp chưa phù hợp thực tế ẩm thực.</a:t>
             </a:r>
           </a:p>
         </p:txBody>
@@ -19807,7 +20011,7 @@
                 <a:ea typeface="Calibri"/>
                 <a:cs typeface="Calibri"/>
               </a:rPr>
-              <a:t>Minh họa thực đơn 4 bữa và phân tích radar dinh dưỡng đa lượng thực tế</a:t>
+              <a:t>Minh họa nghiệm tối ưu kỹ thuật và giới hạn về tính thực tế ẩm thực</a:t>
             </a:r>
           </a:p>
         </p:txBody>
@@ -20958,7 +21162,7 @@
                 <a:ea typeface="Calibri"/>
                 <a:cs typeface="Calibri"/>
               </a:rPr>
-              <a:t>ĐÁNH GIÁ TÍNH ỨNG DỤNG Y TẾ TRÊN P1, P2 VÀ P3</a:t>
+              <a:t>ĐÁNH GIÁ RÀNG BUỘC DINH DƯỠNG THEO BA HỒ SƠ MÔ PHỎNG</a:t>
             </a:r>
           </a:p>
         </p:txBody>
@@ -21002,7 +21206,7 @@
                 <a:ea typeface="Calibri"/>
                 <a:cs typeface="Calibri"/>
               </a:rPr>
-              <a:t>Mở Rộng Ba Hồ Sơ Bệnh Lý Lâm Sàng (Multi-Profile Benchmark)</a:t>
+              <a:t>Mở Rộng Ba Hồ Sơ Dinh Dưỡng Mô Phỏng (Multi-Profile Benchmark)</a:t>
             </a:r>
           </a:p>
         </p:txBody>
@@ -21452,7 +21656,7 @@
                 <a:ea typeface="Calibri"/>
                 <a:cs typeface="Calibri"/>
               </a:rPr>
-              <a:t>PROFILE P2: TIỂU ĐƯỜNG (DIABETES)</a:t>
+              <a:t>PROFILE P2: ĐỊNH HƯỚNG GIẢM CARBOHYDRATE</a:t>
             </a:r>
           </a:p>
         </p:txBody>
@@ -21496,7 +21700,7 @@
                 <a:ea typeface="Calibri"/>
                 <a:cs typeface="Calibri"/>
               </a:rPr>
-              <a:t>Bệnh nhân ĐTĐ Type 2: Nguyễn Thị Lan (45 tuổi)</a:t>
+              <a:t>Hồ sơ mô phỏng P2: Nguyễn Thị Lan (45 tuổi)</a:t>
             </a:r>
           </a:p>
         </p:txBody>
@@ -21588,9 +21792,8 @@
 • Mức vận động: LIGHT (Vận động nhẹ).
 • Mục tiêu: Giảm cân nhẹ (LOSE_WEIGHT, TDEE - 500).
 • Nhu cầu Năng lượng: 1.179,6 kcal/ngày.
-• ĐỊNH HƯỚNG DINH DƯỠNG: Giảm Carbs &amp; kiểm soát calo chặt chẽ.
-• Minh bạch học thuật: CSDL chưa có cột đường tổng (sugar_g);
-  hệ thống dùng proxy carbs 15% để thử nghiệm kỹ thuật, chưa tuyên bố y tế.
+• Định hướng: giảm Carbs và kiểm soát calo chặt chẽ.
+• CSDL chưa có total sugar; proxy 15% Carbs chỉ thử nghiệm kỹ thuật, không dùng để kết luận y tế.
 • Cơ cấu bữa: Sáng (2), Trưa (2), Tối (2), Phụ (1).</a:t>
             </a:r>
           </a:p>
@@ -21769,7 +21972,7 @@
                 <a:ea typeface="Calibri"/>
                 <a:cs typeface="Calibri"/>
               </a:rPr>
-              <a:t>Bệnh nhân Tim mạch: Trần Văn Minh (55 tuổi)</a:t>
+              <a:t>Hồ sơ mô phỏng P3: Trần Văn Minh (55 tuổi)</a:t>
             </a:r>
           </a:p>
         </p:txBody>
@@ -21862,7 +22065,7 @@
 • Mục tiêu: Duy trì cân nặng (MAINTAIN).
 • Nhu cầu Năng lượng: 1.836,0 kcal/ngày.
 • RÀNG BUỘC NGHIÊM NGẶT: Natri &lt;= 1.500 mg/ngày.
-• Tiêu chuẩn AHA (Hiệp hội Tim mạch Hoa Kỳ).
+• Ngưỡng 1.500 mg/ngày được dùng làm mức tham chiếu thử nghiệm.
 • Cơ cấu bữa: Sáng (2), Trưa (2), Tối (2), Phụ (1).</a:t>
             </a:r>
           </a:p>
@@ -21951,7 +22154,7 @@
                 <a:ea typeface="Calibri"/>
                 <a:cs typeface="Calibri"/>
               </a:rPr>
-              <a:t>Thiết lập ba hồ sơ đánh giá và hệ thống ràng buộc bệnh lý lâm sàng</a:t>
+              <a:t>Thiết lập ba hồ sơ mô phỏng và ràng buộc dinh dưỡng theo hồ sơ</a:t>
             </a:r>
           </a:p>
         </p:txBody>

</xml_diff>

<commit_message>
fix(slides): fix slide 13 table overflow, remove canvas warning on slide 1, and align nutrition terminology on slides 3 and 10
</commit_message>
<xml_diff>
--- a/docs/slides/Slide_Bao_Cao_Tuan_8_9_DBO_IDBO.pptx
+++ b/docs/slides/Slide_Bao_Cao_Tuan_8_9_DBO_IDBO.pptx
@@ -3094,6 +3094,14 @@
 <file path=ppt/slides/slide1.xml><?xml version="1.0" encoding="utf-8"?>
 <p:sld xmlns:a="http://schemas.openxmlformats.org/drawingml/2006/main" xmlns:p="http://schemas.openxmlformats.org/presentationml/2006/main" xmlns:r="http://schemas.openxmlformats.org/officeDocument/2006/relationships">
   <p:cSld>
+    <p:bg>
+      <p:bgPr>
+        <a:solidFill>
+          <a:srgbClr val="1B2A4A"/>
+        </a:solidFill>
+        <a:effectLst/>
+      </p:bgPr>
+    </p:bg>
     <p:spTree>
       <p:nvGrpSpPr>
         <p:cNvPr id="1" name=""/>
@@ -3110,50 +3118,6 @@
         <p:spPr>
           <a:xfrm>
             <a:off x="9144" y="9144"/>
-            <a:ext cx="12173407" cy="6839712"/>
-          </a:xfrm>
-          <a:prstGeom prst="rect">
-            <a:avLst/>
-          </a:prstGeom>
-          <a:solidFill>
-            <a:srgbClr val="1B2A4A"/>
-          </a:solidFill>
-          <a:ln>
-            <a:noFill/>
-          </a:ln>
-          <a:effectLst/>
-        </p:spPr>
-        <p:style>
-          <a:lnRef idx="1">
-            <a:schemeClr val="accent1"/>
-          </a:lnRef>
-          <a:fillRef idx="3">
-            <a:schemeClr val="accent1"/>
-          </a:fillRef>
-          <a:effectRef idx="2">
-            <a:schemeClr val="accent1"/>
-          </a:effectRef>
-          <a:fontRef idx="minor">
-            <a:schemeClr val="lt1"/>
-          </a:fontRef>
-        </p:style>
-        <p:txBody>
-          <a:bodyPr rtlCol="0" anchor="ctr"/>
-          <a:lstStyle/>
-          <a:p>
-            <a:pPr algn="ctr"/>
-          </a:p>
-        </p:txBody>
-      </p:sp>
-      <p:sp>
-        <p:nvSpPr>
-          <p:cNvPr id="3" name="Rectangle 2"/>
-          <p:cNvSpPr/>
-          <p:nvPr/>
-        </p:nvSpPr>
-        <p:spPr>
-          <a:xfrm>
-            <a:off x="9144" y="9144"/>
             <a:ext cx="12173407" cy="155448"/>
           </a:xfrm>
           <a:prstGeom prst="rect">
@@ -3191,7 +3155,7 @@
       </p:sp>
       <p:sp>
         <p:nvSpPr>
-          <p:cNvPr id="4" name="TextBox 3"/>
+          <p:cNvPr id="3" name="TextBox 2"/>
           <p:cNvSpPr txBox="1"/>
           <p:nvPr/>
         </p:nvSpPr>
@@ -3235,7 +3199,7 @@
       </p:sp>
       <p:sp>
         <p:nvSpPr>
-          <p:cNvPr id="5" name="Rectangle 4"/>
+          <p:cNvPr id="4" name="Rectangle 3"/>
           <p:cNvSpPr/>
           <p:nvPr/>
         </p:nvSpPr>
@@ -3279,7 +3243,7 @@
       </p:sp>
       <p:sp>
         <p:nvSpPr>
-          <p:cNvPr id="6" name="TextBox 5"/>
+          <p:cNvPr id="5" name="TextBox 4"/>
           <p:cNvSpPr txBox="1"/>
           <p:nvPr/>
         </p:nvSpPr>
@@ -3323,7 +3287,7 @@
       </p:sp>
       <p:sp>
         <p:nvSpPr>
-          <p:cNvPr id="7" name="TextBox 6"/>
+          <p:cNvPr id="6" name="TextBox 5"/>
           <p:cNvSpPr txBox="1"/>
           <p:nvPr/>
         </p:nvSpPr>
@@ -3367,7 +3331,7 @@
       </p:sp>
       <p:sp>
         <p:nvSpPr>
-          <p:cNvPr id="8" name="TextBox 7"/>
+          <p:cNvPr id="7" name="TextBox 6"/>
           <p:cNvSpPr txBox="1"/>
           <p:nvPr/>
         </p:nvSpPr>
@@ -3411,7 +3375,7 @@
       </p:sp>
       <p:sp>
         <p:nvSpPr>
-          <p:cNvPr id="9" name="TextBox 8"/>
+          <p:cNvPr id="8" name="TextBox 7"/>
           <p:cNvSpPr txBox="1"/>
           <p:nvPr/>
         </p:nvSpPr>
@@ -3455,7 +3419,7 @@
       </p:sp>
       <p:sp>
         <p:nvSpPr>
-          <p:cNvPr id="10" name="Rectangle 9"/>
+          <p:cNvPr id="9" name="Rectangle 8"/>
           <p:cNvSpPr/>
           <p:nvPr/>
         </p:nvSpPr>
@@ -3499,7 +3463,7 @@
       </p:sp>
       <p:sp>
         <p:nvSpPr>
-          <p:cNvPr id="11" name="TextBox 10"/>
+          <p:cNvPr id="10" name="TextBox 9"/>
           <p:cNvSpPr txBox="1"/>
           <p:nvPr/>
         </p:nvSpPr>
@@ -3618,7 +3582,7 @@
       </p:sp>
       <p:sp>
         <p:nvSpPr>
-          <p:cNvPr id="12" name="TextBox 11"/>
+          <p:cNvPr id="11" name="TextBox 10"/>
           <p:cNvSpPr txBox="1"/>
           <p:nvPr/>
         </p:nvSpPr>
@@ -3761,7 +3725,7 @@
                 <a:ea typeface="Calibri"/>
                 <a:cs typeface="Calibri"/>
               </a:rPr>
-              <a:t>ĐỐI CHUẨN THUẬT TOÁN VÀ ĐÁNH GIÁ MỨC ĐỘ THỎA MÃN BỆNH LÝ</a:t>
+              <a:t>ĐỐI CHUẨN THUẬT TOÁN VÀ ĐÁNH GIÁ RÀNG BUỘC DINH DƯỠNG THEO HỒ SƠ</a:t>
             </a:r>
           </a:p>
         </p:txBody>
@@ -3923,7 +3887,7 @@
                           <a:ea typeface="Calibri"/>
                           <a:cs typeface="Calibri"/>
                         </a:rPr>
-                        <a:t>Hồ sơ bệnh lý</a:t>
+                        <a:t>Hồ sơ dinh dưỡng</a:t>
                       </a:r>
                     </a:p>
                   </a:txBody>
@@ -4327,7 +4291,7 @@
                           <a:ea typeface="Calibri"/>
                           <a:cs typeface="Calibri"/>
                         </a:rPr>
-                        <a:t>P2 (Tiểu đường)</a:t>
+                        <a:t>P2 (Giảm Carbs)</a:t>
                       </a:r>
                     </a:p>
                   </a:txBody>
@@ -4529,7 +4493,7 @@
                           <a:ea typeface="Calibri"/>
                           <a:cs typeface="Calibri"/>
                         </a:rPr>
-                        <a:t>P3 (Huyết áp)</a:t>
+                        <a:t>P3 (Giới hạn Natri)</a:t>
                       </a:r>
                     </a:p>
                   </a:txBody>
@@ -4933,7 +4897,7 @@
                           <a:ea typeface="Calibri"/>
                           <a:cs typeface="Calibri"/>
                         </a:rPr>
-                        <a:t>P2 (Tiểu đường)</a:t>
+                        <a:t>P2 (Giảm Carbs)</a:t>
                       </a:r>
                     </a:p>
                   </a:txBody>
@@ -5135,7 +5099,7 @@
                           <a:ea typeface="Calibri"/>
                           <a:cs typeface="Calibri"/>
                         </a:rPr>
-                        <a:t>P3 (Huyết áp)</a:t>
+                        <a:t>P3 (Giới hạn Natri)</a:t>
                       </a:r>
                     </a:p>
                   </a:txBody>
@@ -8366,7 +8330,7 @@
         </p:nvGraphicFramePr>
         <p:xfrm>
           <a:off x="640080" y="1828800"/>
-          <a:ext cx="5166359" cy="5138928"/>
+          <a:ext cx="5166359" cy="3602736"/>
         </p:xfrm>
         <a:graphic>
           <a:graphicData uri="http://schemas.openxmlformats.org/drawingml/2006/table">
@@ -8482,7 +8446,7 @@
                   </a:tcPr>
                 </a:tc>
               </a:tr>
-              <a:tr h="475488">
+              <a:tr h="402336">
                 <a:tc>
                   <a:txBody>
                     <a:bodyPr/>
@@ -8490,7 +8454,7 @@
                     <a:p>
                       <a:pPr algn="l"/>
                       <a:r>
-                        <a:rPr sz="900" b="1" i="0">
+                        <a:rPr sz="850" b="1" i="0">
                           <a:solidFill>
                             <a:srgbClr val="1E2430"/>
                           </a:solidFill>
@@ -8515,7 +8479,7 @@
                     <a:p>
                       <a:pPr algn="ctr"/>
                       <a:r>
-                        <a:rPr sz="900" b="0" i="0">
+                        <a:rPr sz="850" b="0" i="0">
                           <a:solidFill>
                             <a:srgbClr val="1E2430"/>
                           </a:solidFill>
@@ -8540,7 +8504,7 @@
                     <a:p>
                       <a:pPr algn="l"/>
                       <a:r>
-                        <a:rPr sz="900" b="0" i="0">
+                        <a:rPr sz="850" b="0" i="0">
                           <a:solidFill>
                             <a:srgbClr val="1E2430"/>
                           </a:solidFill>
@@ -8565,7 +8529,7 @@
                     <a:p>
                       <a:pPr algn="ctr"/>
                       <a:r>
-                        <a:rPr sz="900" b="1" i="0">
+                        <a:rPr sz="850" b="1" i="0">
                           <a:solidFill>
                             <a:srgbClr val="217A4B"/>
                           </a:solidFill>
@@ -8584,7 +8548,7 @@
                   </a:tcPr>
                 </a:tc>
               </a:tr>
-              <a:tr h="475488">
+              <a:tr h="402336">
                 <a:tc>
                   <a:txBody>
                     <a:bodyPr/>
@@ -8592,7 +8556,7 @@
                     <a:p>
                       <a:pPr algn="l"/>
                       <a:r>
-                        <a:rPr sz="900" b="1" i="0">
+                        <a:rPr sz="850" b="1" i="0">
                           <a:solidFill>
                             <a:srgbClr val="1E2430"/>
                           </a:solidFill>
@@ -8617,7 +8581,7 @@
                     <a:p>
                       <a:pPr algn="ctr"/>
                       <a:r>
-                        <a:rPr sz="900" b="0" i="0">
+                        <a:rPr sz="850" b="0" i="0">
                           <a:solidFill>
                             <a:srgbClr val="1E2430"/>
                           </a:solidFill>
@@ -8642,7 +8606,7 @@
                     <a:p>
                       <a:pPr algn="l"/>
                       <a:r>
-                        <a:rPr sz="900" b="0" i="0">
+                        <a:rPr sz="850" b="0" i="0">
                           <a:solidFill>
                             <a:srgbClr val="1E2430"/>
                           </a:solidFill>
@@ -8667,7 +8631,7 @@
                     <a:p>
                       <a:pPr algn="ctr"/>
                       <a:r>
-                        <a:rPr sz="900" b="1" i="0">
+                        <a:rPr sz="850" b="1" i="0">
                           <a:solidFill>
                             <a:srgbClr val="217A4B"/>
                           </a:solidFill>
@@ -8686,7 +8650,7 @@
                   </a:tcPr>
                 </a:tc>
               </a:tr>
-              <a:tr h="475488">
+              <a:tr h="402336">
                 <a:tc>
                   <a:txBody>
                     <a:bodyPr/>
@@ -8694,7 +8658,7 @@
                     <a:p>
                       <a:pPr algn="l"/>
                       <a:r>
-                        <a:rPr sz="900" b="1" i="0">
+                        <a:rPr sz="850" b="1" i="0">
                           <a:solidFill>
                             <a:srgbClr val="1E2430"/>
                           </a:solidFill>
@@ -8719,7 +8683,7 @@
                     <a:p>
                       <a:pPr algn="ctr"/>
                       <a:r>
-                        <a:rPr sz="900" b="0" i="0">
+                        <a:rPr sz="850" b="0" i="0">
                           <a:solidFill>
                             <a:srgbClr val="1E2430"/>
                           </a:solidFill>
@@ -8744,7 +8708,7 @@
                     <a:p>
                       <a:pPr algn="l"/>
                       <a:r>
-                        <a:rPr sz="900" b="0" i="0">
+                        <a:rPr sz="850" b="0" i="0">
                           <a:solidFill>
                             <a:srgbClr val="1E2430"/>
                           </a:solidFill>
@@ -8769,7 +8733,7 @@
                     <a:p>
                       <a:pPr algn="ctr"/>
                       <a:r>
-                        <a:rPr sz="900" b="1" i="0">
+                        <a:rPr sz="850" b="1" i="0">
                           <a:solidFill>
                             <a:srgbClr val="217A4B"/>
                           </a:solidFill>
@@ -8788,7 +8752,7 @@
                   </a:tcPr>
                 </a:tc>
               </a:tr>
-              <a:tr h="475488">
+              <a:tr h="402336">
                 <a:tc>
                   <a:txBody>
                     <a:bodyPr/>
@@ -8796,7 +8760,7 @@
                     <a:p>
                       <a:pPr algn="l"/>
                       <a:r>
-                        <a:rPr sz="900" b="1" i="0">
+                        <a:rPr sz="850" b="1" i="0">
                           <a:solidFill>
                             <a:srgbClr val="1E2430"/>
                           </a:solidFill>
@@ -8821,7 +8785,7 @@
                     <a:p>
                       <a:pPr algn="ctr"/>
                       <a:r>
-                        <a:rPr sz="900" b="0" i="0">
+                        <a:rPr sz="850" b="0" i="0">
                           <a:solidFill>
                             <a:srgbClr val="1E2430"/>
                           </a:solidFill>
@@ -8846,7 +8810,7 @@
                     <a:p>
                       <a:pPr algn="l"/>
                       <a:r>
-                        <a:rPr sz="900" b="0" i="0">
+                        <a:rPr sz="850" b="0" i="0">
                           <a:solidFill>
                             <a:srgbClr val="1E2430"/>
                           </a:solidFill>
@@ -8871,7 +8835,7 @@
                     <a:p>
                       <a:pPr algn="ctr"/>
                       <a:r>
-                        <a:rPr sz="900" b="1" i="0">
+                        <a:rPr sz="850" b="1" i="0">
                           <a:solidFill>
                             <a:srgbClr val="217A4B"/>
                           </a:solidFill>
@@ -8890,7 +8854,7 @@
                   </a:tcPr>
                 </a:tc>
               </a:tr>
-              <a:tr h="475488">
+              <a:tr h="402336">
                 <a:tc>
                   <a:txBody>
                     <a:bodyPr/>
@@ -8898,7 +8862,7 @@
                     <a:p>
                       <a:pPr algn="l"/>
                       <a:r>
-                        <a:rPr sz="900" b="1" i="0">
+                        <a:rPr sz="850" b="1" i="0">
                           <a:solidFill>
                             <a:srgbClr val="1E2430"/>
                           </a:solidFill>
@@ -8923,7 +8887,7 @@
                     <a:p>
                       <a:pPr algn="ctr"/>
                       <a:r>
-                        <a:rPr sz="900" b="0" i="0">
+                        <a:rPr sz="850" b="0" i="0">
                           <a:solidFill>
                             <a:srgbClr val="1E2430"/>
                           </a:solidFill>
@@ -8948,7 +8912,7 @@
                     <a:p>
                       <a:pPr algn="l"/>
                       <a:r>
-                        <a:rPr sz="900" b="0" i="0">
+                        <a:rPr sz="850" b="0" i="0">
                           <a:solidFill>
                             <a:srgbClr val="1E2430"/>
                           </a:solidFill>
@@ -8973,7 +8937,7 @@
                     <a:p>
                       <a:pPr algn="ctr"/>
                       <a:r>
-                        <a:rPr sz="900" b="1" i="0">
+                        <a:rPr sz="850" b="1" i="0">
                           <a:solidFill>
                             <a:srgbClr val="217A4B"/>
                           </a:solidFill>
@@ -8992,7 +8956,7 @@
                   </a:tcPr>
                 </a:tc>
               </a:tr>
-              <a:tr h="475488">
+              <a:tr h="402336">
                 <a:tc>
                   <a:txBody>
                     <a:bodyPr/>
@@ -9000,7 +8964,7 @@
                     <a:p>
                       <a:pPr algn="l"/>
                       <a:r>
-                        <a:rPr sz="900" b="1" i="0">
+                        <a:rPr sz="850" b="1" i="0">
                           <a:solidFill>
                             <a:srgbClr val="1E2430"/>
                           </a:solidFill>
@@ -9025,7 +8989,7 @@
                     <a:p>
                       <a:pPr algn="ctr"/>
                       <a:r>
-                        <a:rPr sz="900" b="0" i="0">
+                        <a:rPr sz="850" b="0" i="0">
                           <a:solidFill>
                             <a:srgbClr val="1E2430"/>
                           </a:solidFill>
@@ -9050,7 +9014,7 @@
                     <a:p>
                       <a:pPr algn="l"/>
                       <a:r>
-                        <a:rPr sz="900" b="0" i="0">
+                        <a:rPr sz="850" b="0" i="0">
                           <a:solidFill>
                             <a:srgbClr val="1E2430"/>
                           </a:solidFill>
@@ -9075,7 +9039,7 @@
                     <a:p>
                       <a:pPr algn="ctr"/>
                       <a:r>
-                        <a:rPr sz="900" b="1" i="0">
+                        <a:rPr sz="850" b="1" i="0">
                           <a:solidFill>
                             <a:srgbClr val="217A4B"/>
                           </a:solidFill>
@@ -9094,7 +9058,7 @@
                   </a:tcPr>
                 </a:tc>
               </a:tr>
-              <a:tr h="475488">
+              <a:tr h="402336">
                 <a:tc>
                   <a:txBody>
                     <a:bodyPr/>
@@ -9102,7 +9066,7 @@
                     <a:p>
                       <a:pPr algn="l"/>
                       <a:r>
-                        <a:rPr sz="900" b="1" i="0">
+                        <a:rPr sz="850" b="1" i="0">
                           <a:solidFill>
                             <a:srgbClr val="1E2430"/>
                           </a:solidFill>
@@ -9110,7 +9074,7 @@
                           <a:ea typeface="Calibri"/>
                           <a:cs typeface="Calibri"/>
                         </a:rPr>
-                        <a:t>test_data_integrity.py</a:t>
+                        <a:t>Data, Culinary &amp; Constraints</a:t>
                       </a:r>
                     </a:p>
                   </a:txBody>
@@ -9127,7 +9091,7 @@
                     <a:p>
                       <a:pPr algn="ctr"/>
                       <a:r>
-                        <a:rPr sz="900" b="0" i="0">
+                        <a:rPr sz="850" b="0" i="0">
                           <a:solidFill>
                             <a:srgbClr val="1E2430"/>
                           </a:solidFill>
@@ -9135,7 +9099,7 @@
                           <a:ea typeface="Calibri"/>
                           <a:cs typeface="Calibri"/>
                         </a:rPr>
-                        <a:t>5 tests</a:t>
+                        <a:t>14 tests</a:t>
                       </a:r>
                     </a:p>
                   </a:txBody>
@@ -9152,7 +9116,7 @@
                     <a:p>
                       <a:pPr algn="l"/>
                       <a:r>
-                        <a:rPr sz="900" b="0" i="0">
+                        <a:rPr sz="850" b="0" i="0">
                           <a:solidFill>
                             <a:srgbClr val="1E2430"/>
                           </a:solidFill>
@@ -9160,7 +9124,7 @@
                           <a:ea typeface="Calibri"/>
                           <a:cs typeface="Calibri"/>
                         </a:rPr>
-                        <a:t>Schema dữ liệu; chặn nguyên liệu thô không phù hợp</a:t>
+                        <a:t>Schema dữ liệu, ẩm thực Slot &amp; Natri huyết áp</a:t>
                       </a:r>
                     </a:p>
                   </a:txBody>
@@ -9177,7 +9141,7 @@
                     <a:p>
                       <a:pPr algn="ctr"/>
                       <a:r>
-                        <a:rPr sz="900" b="1" i="0">
+                        <a:rPr sz="850" b="1" i="0">
                           <a:solidFill>
                             <a:srgbClr val="217A4B"/>
                           </a:solidFill>
@@ -9196,7 +9160,7 @@
                   </a:tcPr>
                 </a:tc>
               </a:tr>
-              <a:tr h="475488">
+              <a:tr h="402336">
                 <a:tc>
                   <a:txBody>
                     <a:bodyPr/>
@@ -9204,211 +9168,7 @@
                     <a:p>
                       <a:pPr algn="l"/>
                       <a:r>
-                        <a:rPr sz="900" b="1" i="0">
-                          <a:solidFill>
-                            <a:srgbClr val="1E2430"/>
-                          </a:solidFill>
-                          <a:latin typeface="Calibri"/>
-                          <a:ea typeface="Calibri"/>
-                          <a:cs typeface="Calibri"/>
-                        </a:rPr>
-                        <a:t>test_culinary_realism.py</a:t>
-                      </a:r>
-                    </a:p>
-                  </a:txBody>
-                  <a:tcPr marL="73152" marR="73152" marT="27432" marB="27432" anchor="ctr">
-                    <a:solidFill>
-                      <a:srgbClr val="FFFFFF"/>
-                    </a:solidFill>
-                  </a:tcPr>
-                </a:tc>
-                <a:tc>
-                  <a:txBody>
-                    <a:bodyPr/>
-                    <a:lstStyle/>
-                    <a:p>
-                      <a:pPr algn="ctr"/>
-                      <a:r>
-                        <a:rPr sz="900" b="0" i="0">
-                          <a:solidFill>
-                            <a:srgbClr val="1E2430"/>
-                          </a:solidFill>
-                          <a:latin typeface="Calibri"/>
-                          <a:ea typeface="Calibri"/>
-                          <a:cs typeface="Calibri"/>
-                        </a:rPr>
-                        <a:t>2 tests</a:t>
-                      </a:r>
-                    </a:p>
-                  </a:txBody>
-                  <a:tcPr marL="73152" marR="73152" marT="27432" marB="27432" anchor="ctr">
-                    <a:solidFill>
-                      <a:srgbClr val="FFFFFF"/>
-                    </a:solidFill>
-                  </a:tcPr>
-                </a:tc>
-                <a:tc>
-                  <a:txBody>
-                    <a:bodyPr/>
-                    <a:lstStyle/>
-                    <a:p>
-                      <a:pPr algn="l"/>
-                      <a:r>
-                        <a:rPr sz="900" b="0" i="0">
-                          <a:solidFill>
-                            <a:srgbClr val="1E2430"/>
-                          </a:solidFill>
-                          <a:latin typeface="Calibri"/>
-                          <a:ea typeface="Calibri"/>
-                          <a:cs typeface="Calibri"/>
-                        </a:rPr>
-                        <a:t>Kiểm tra cơ cấu món theo Culinary Slots</a:t>
-                      </a:r>
-                    </a:p>
-                  </a:txBody>
-                  <a:tcPr marL="73152" marR="73152" marT="27432" marB="27432" anchor="ctr">
-                    <a:solidFill>
-                      <a:srgbClr val="FFFFFF"/>
-                    </a:solidFill>
-                  </a:tcPr>
-                </a:tc>
-                <a:tc>
-                  <a:txBody>
-                    <a:bodyPr/>
-                    <a:lstStyle/>
-                    <a:p>
-                      <a:pPr algn="ctr"/>
-                      <a:r>
-                        <a:rPr sz="900" b="1" i="0">
-                          <a:solidFill>
-                            <a:srgbClr val="217A4B"/>
-                          </a:solidFill>
-                          <a:latin typeface="Calibri"/>
-                          <a:ea typeface="Calibri"/>
-                          <a:cs typeface="Calibri"/>
-                        </a:rPr>
-                        <a:t>PASS 100%</a:t>
-                      </a:r>
-                    </a:p>
-                  </a:txBody>
-                  <a:tcPr marL="73152" marR="73152" marT="27432" marB="27432" anchor="ctr">
-                    <a:solidFill>
-                      <a:srgbClr val="FFFFFF"/>
-                    </a:solidFill>
-                  </a:tcPr>
-                </a:tc>
-              </a:tr>
-              <a:tr h="475488">
-                <a:tc>
-                  <a:txBody>
-                    <a:bodyPr/>
-                    <a:lstStyle/>
-                    <a:p>
-                      <a:pPr algn="l"/>
-                      <a:r>
-                        <a:rPr sz="900" b="1" i="0">
-                          <a:solidFill>
-                            <a:srgbClr val="1E2430"/>
-                          </a:solidFill>
-                          <a:latin typeface="Calibri"/>
-                          <a:ea typeface="Calibri"/>
-                          <a:cs typeface="Calibri"/>
-                        </a:rPr>
-                        <a:t>test_constraints.py</a:t>
-                      </a:r>
-                    </a:p>
-                  </a:txBody>
-                  <a:tcPr marL="73152" marR="73152" marT="27432" marB="27432" anchor="ctr">
-                    <a:solidFill>
-                      <a:srgbClr val="F5F7FB"/>
-                    </a:solidFill>
-                  </a:tcPr>
-                </a:tc>
-                <a:tc>
-                  <a:txBody>
-                    <a:bodyPr/>
-                    <a:lstStyle/>
-                    <a:p>
-                      <a:pPr algn="ctr"/>
-                      <a:r>
-                        <a:rPr sz="900" b="0" i="0">
-                          <a:solidFill>
-                            <a:srgbClr val="1E2430"/>
-                          </a:solidFill>
-                          <a:latin typeface="Calibri"/>
-                          <a:ea typeface="Calibri"/>
-                          <a:cs typeface="Calibri"/>
-                        </a:rPr>
-                        <a:t>7 tests</a:t>
-                      </a:r>
-                    </a:p>
-                  </a:txBody>
-                  <a:tcPr marL="73152" marR="73152" marT="27432" marB="27432" anchor="ctr">
-                    <a:solidFill>
-                      <a:srgbClr val="F5F7FB"/>
-                    </a:solidFill>
-                  </a:tcPr>
-                </a:tc>
-                <a:tc>
-                  <a:txBody>
-                    <a:bodyPr/>
-                    <a:lstStyle/>
-                    <a:p>
-                      <a:pPr algn="l"/>
-                      <a:r>
-                        <a:rPr sz="900" b="0" i="0">
-                          <a:solidFill>
-                            <a:srgbClr val="1E2430"/>
-                          </a:solidFill>
-                          <a:latin typeface="Calibri"/>
-                          <a:ea typeface="Calibri"/>
-                          <a:cs typeface="Calibri"/>
-                        </a:rPr>
-                        <a:t>Bổ sung ràng buộc Natri cho profile tăng huyết áp</a:t>
-                      </a:r>
-                    </a:p>
-                  </a:txBody>
-                  <a:tcPr marL="73152" marR="73152" marT="27432" marB="27432" anchor="ctr">
-                    <a:solidFill>
-                      <a:srgbClr val="F5F7FB"/>
-                    </a:solidFill>
-                  </a:tcPr>
-                </a:tc>
-                <a:tc>
-                  <a:txBody>
-                    <a:bodyPr/>
-                    <a:lstStyle/>
-                    <a:p>
-                      <a:pPr algn="ctr"/>
-                      <a:r>
-                        <a:rPr sz="900" b="1" i="0">
-                          <a:solidFill>
-                            <a:srgbClr val="217A4B"/>
-                          </a:solidFill>
-                          <a:latin typeface="Calibri"/>
-                          <a:ea typeface="Calibri"/>
-                          <a:cs typeface="Calibri"/>
-                        </a:rPr>
-                        <a:t>PASS 100%</a:t>
-                      </a:r>
-                    </a:p>
-                  </a:txBody>
-                  <a:tcPr marL="73152" marR="73152" marT="27432" marB="27432" anchor="ctr">
-                    <a:solidFill>
-                      <a:srgbClr val="F5F7FB"/>
-                    </a:solidFill>
-                  </a:tcPr>
-                </a:tc>
-              </a:tr>
-              <a:tr h="475488">
-                <a:tc>
-                  <a:txBody>
-                    <a:bodyPr/>
-                    <a:lstStyle/>
-                    <a:p>
-                      <a:pPr algn="l"/>
-                      <a:r>
-                        <a:rPr sz="900" b="1" i="0">
+                        <a:rPr sz="850" b="1" i="0">
                           <a:solidFill>
                             <a:srgbClr val="1E2430"/>
                           </a:solidFill>
@@ -9433,7 +9193,7 @@
                     <a:p>
                       <a:pPr algn="ctr"/>
                       <a:r>
-                        <a:rPr sz="900" b="0" i="0">
+                        <a:rPr sz="850" b="0" i="0">
                           <a:solidFill>
                             <a:srgbClr val="1E2430"/>
                           </a:solidFill>
@@ -9458,7 +9218,7 @@
                     <a:p>
                       <a:pPr algn="l"/>
                       <a:r>
-                        <a:rPr sz="900" b="0" i="0">
+                        <a:rPr sz="850" b="0" i="0">
                           <a:solidFill>
                             <a:srgbClr val="1E2430"/>
                           </a:solidFill>
@@ -9483,7 +9243,7 @@
                     <a:p>
                       <a:pPr algn="ctr"/>
                       <a:r>
-                        <a:rPr sz="900" b="1" i="0">
+                        <a:rPr sz="850" b="1" i="0">
                           <a:solidFill>
                             <a:srgbClr val="217A4B"/>
                           </a:solidFill>
@@ -13703,7 +13463,7 @@
                 <a:ea typeface="Calibri"/>
                 <a:cs typeface="Calibri"/>
               </a:rPr>
-              <a:t>• Hàm mục tiêu kết hợp phạt vi phạm năng lượng, dinh dưỡng đa lượng và bệnh lý.
+              <a:t>• Hàm mục tiêu kết hợp phạt vi phạm năng lượng, dinh dưỡng đa lượng và các giới hạn dinh dưỡng có dữ liệu hỗ trợ.
 • Thời gian giải nhanh: 0.17–0.30s cho mỗi lần chạy Inner (chạy tốt).</a:t>
             </a:r>
           </a:p>

</xml_diff>

<commit_message>
docs(slides): apply presentation clarity patch and regenerate slide deck
</commit_message>
<xml_diff>
--- a/docs/slides/Slide_Bao_Cao_Tuan_8_9_DBO_IDBO.pptx
+++ b/docs/slides/Slide_Bao_Cao_Tuan_8_9_DBO_IDBO.pptx
@@ -8330,7 +8330,7 @@
         </p:nvGraphicFramePr>
         <p:xfrm>
           <a:off x="640080" y="1828800"/>
-          <a:ext cx="5166359" cy="3602736"/>
+          <a:ext cx="5166359" cy="3236976"/>
         </p:xfrm>
         <a:graphic>
           <a:graphicData uri="http://schemas.openxmlformats.org/drawingml/2006/table">
@@ -8446,7 +8446,7 @@
                   </a:tcPr>
                 </a:tc>
               </a:tr>
-              <a:tr h="402336">
+              <a:tr h="356616">
                 <a:tc>
                   <a:txBody>
                     <a:bodyPr/>
@@ -8454,7 +8454,7 @@
                     <a:p>
                       <a:pPr algn="l"/>
                       <a:r>
-                        <a:rPr sz="850" b="1" i="0">
+                        <a:rPr sz="760" b="1" i="0">
                           <a:solidFill>
                             <a:srgbClr val="1E2430"/>
                           </a:solidFill>
@@ -8479,7 +8479,7 @@
                     <a:p>
                       <a:pPr algn="ctr"/>
                       <a:r>
-                        <a:rPr sz="850" b="0" i="0">
+                        <a:rPr sz="760" b="0" i="0">
                           <a:solidFill>
                             <a:srgbClr val="1E2430"/>
                           </a:solidFill>
@@ -8504,7 +8504,7 @@
                     <a:p>
                       <a:pPr algn="l"/>
                       <a:r>
-                        <a:rPr sz="850" b="0" i="0">
+                        <a:rPr sz="760" b="0" i="0">
                           <a:solidFill>
                             <a:srgbClr val="1E2430"/>
                           </a:solidFill>
@@ -8529,7 +8529,7 @@
                     <a:p>
                       <a:pPr algn="ctr"/>
                       <a:r>
-                        <a:rPr sz="850" b="1" i="0">
+                        <a:rPr sz="760" b="1" i="0">
                           <a:solidFill>
                             <a:srgbClr val="217A4B"/>
                           </a:solidFill>
@@ -8548,7 +8548,7 @@
                   </a:tcPr>
                 </a:tc>
               </a:tr>
-              <a:tr h="402336">
+              <a:tr h="356616">
                 <a:tc>
                   <a:txBody>
                     <a:bodyPr/>
@@ -8556,7 +8556,7 @@
                     <a:p>
                       <a:pPr algn="l"/>
                       <a:r>
-                        <a:rPr sz="850" b="1" i="0">
+                        <a:rPr sz="760" b="1" i="0">
                           <a:solidFill>
                             <a:srgbClr val="1E2430"/>
                           </a:solidFill>
@@ -8581,7 +8581,7 @@
                     <a:p>
                       <a:pPr algn="ctr"/>
                       <a:r>
-                        <a:rPr sz="850" b="0" i="0">
+                        <a:rPr sz="760" b="0" i="0">
                           <a:solidFill>
                             <a:srgbClr val="1E2430"/>
                           </a:solidFill>
@@ -8606,7 +8606,7 @@
                     <a:p>
                       <a:pPr algn="l"/>
                       <a:r>
-                        <a:rPr sz="850" b="0" i="0">
+                        <a:rPr sz="760" b="0" i="0">
                           <a:solidFill>
                             <a:srgbClr val="1E2430"/>
                           </a:solidFill>
@@ -8631,7 +8631,7 @@
                     <a:p>
                       <a:pPr algn="ctr"/>
                       <a:r>
-                        <a:rPr sz="850" b="1" i="0">
+                        <a:rPr sz="760" b="1" i="0">
                           <a:solidFill>
                             <a:srgbClr val="217A4B"/>
                           </a:solidFill>
@@ -8650,7 +8650,7 @@
                   </a:tcPr>
                 </a:tc>
               </a:tr>
-              <a:tr h="402336">
+              <a:tr h="356616">
                 <a:tc>
                   <a:txBody>
                     <a:bodyPr/>
@@ -8658,7 +8658,7 @@
                     <a:p>
                       <a:pPr algn="l"/>
                       <a:r>
-                        <a:rPr sz="850" b="1" i="0">
+                        <a:rPr sz="760" b="1" i="0">
                           <a:solidFill>
                             <a:srgbClr val="1E2430"/>
                           </a:solidFill>
@@ -8683,7 +8683,7 @@
                     <a:p>
                       <a:pPr algn="ctr"/>
                       <a:r>
-                        <a:rPr sz="850" b="0" i="0">
+                        <a:rPr sz="760" b="0" i="0">
                           <a:solidFill>
                             <a:srgbClr val="1E2430"/>
                           </a:solidFill>
@@ -8708,7 +8708,7 @@
                     <a:p>
                       <a:pPr algn="l"/>
                       <a:r>
-                        <a:rPr sz="850" b="0" i="0">
+                        <a:rPr sz="760" b="0" i="0">
                           <a:solidFill>
                             <a:srgbClr val="1E2430"/>
                           </a:solidFill>
@@ -8733,7 +8733,7 @@
                     <a:p>
                       <a:pPr algn="ctr"/>
                       <a:r>
-                        <a:rPr sz="850" b="1" i="0">
+                        <a:rPr sz="760" b="1" i="0">
                           <a:solidFill>
                             <a:srgbClr val="217A4B"/>
                           </a:solidFill>
@@ -8752,7 +8752,7 @@
                   </a:tcPr>
                 </a:tc>
               </a:tr>
-              <a:tr h="402336">
+              <a:tr h="356616">
                 <a:tc>
                   <a:txBody>
                     <a:bodyPr/>
@@ -8760,7 +8760,7 @@
                     <a:p>
                       <a:pPr algn="l"/>
                       <a:r>
-                        <a:rPr sz="850" b="1" i="0">
+                        <a:rPr sz="760" b="1" i="0">
                           <a:solidFill>
                             <a:srgbClr val="1E2430"/>
                           </a:solidFill>
@@ -8785,7 +8785,7 @@
                     <a:p>
                       <a:pPr algn="ctr"/>
                       <a:r>
-                        <a:rPr sz="850" b="0" i="0">
+                        <a:rPr sz="760" b="0" i="0">
                           <a:solidFill>
                             <a:srgbClr val="1E2430"/>
                           </a:solidFill>
@@ -8810,7 +8810,7 @@
                     <a:p>
                       <a:pPr algn="l"/>
                       <a:r>
-                        <a:rPr sz="850" b="0" i="0">
+                        <a:rPr sz="760" b="0" i="0">
                           <a:solidFill>
                             <a:srgbClr val="1E2430"/>
                           </a:solidFill>
@@ -8835,7 +8835,7 @@
                     <a:p>
                       <a:pPr algn="ctr"/>
                       <a:r>
-                        <a:rPr sz="850" b="1" i="0">
+                        <a:rPr sz="760" b="1" i="0">
                           <a:solidFill>
                             <a:srgbClr val="217A4B"/>
                           </a:solidFill>
@@ -8854,7 +8854,7 @@
                   </a:tcPr>
                 </a:tc>
               </a:tr>
-              <a:tr h="402336">
+              <a:tr h="356616">
                 <a:tc>
                   <a:txBody>
                     <a:bodyPr/>
@@ -8862,7 +8862,7 @@
                     <a:p>
                       <a:pPr algn="l"/>
                       <a:r>
-                        <a:rPr sz="850" b="1" i="0">
+                        <a:rPr sz="760" b="1" i="0">
                           <a:solidFill>
                             <a:srgbClr val="1E2430"/>
                           </a:solidFill>
@@ -8887,7 +8887,7 @@
                     <a:p>
                       <a:pPr algn="ctr"/>
                       <a:r>
-                        <a:rPr sz="850" b="0" i="0">
+                        <a:rPr sz="760" b="0" i="0">
                           <a:solidFill>
                             <a:srgbClr val="1E2430"/>
                           </a:solidFill>
@@ -8912,7 +8912,7 @@
                     <a:p>
                       <a:pPr algn="l"/>
                       <a:r>
-                        <a:rPr sz="850" b="0" i="0">
+                        <a:rPr sz="760" b="0" i="0">
                           <a:solidFill>
                             <a:srgbClr val="1E2430"/>
                           </a:solidFill>
@@ -8937,7 +8937,7 @@
                     <a:p>
                       <a:pPr algn="ctr"/>
                       <a:r>
-                        <a:rPr sz="850" b="1" i="0">
+                        <a:rPr sz="760" b="1" i="0">
                           <a:solidFill>
                             <a:srgbClr val="217A4B"/>
                           </a:solidFill>
@@ -8956,7 +8956,7 @@
                   </a:tcPr>
                 </a:tc>
               </a:tr>
-              <a:tr h="402336">
+              <a:tr h="356616">
                 <a:tc>
                   <a:txBody>
                     <a:bodyPr/>
@@ -8964,7 +8964,7 @@
                     <a:p>
                       <a:pPr algn="l"/>
                       <a:r>
-                        <a:rPr sz="850" b="1" i="0">
+                        <a:rPr sz="760" b="1" i="0">
                           <a:solidFill>
                             <a:srgbClr val="1E2430"/>
                           </a:solidFill>
@@ -8989,7 +8989,7 @@
                     <a:p>
                       <a:pPr algn="ctr"/>
                       <a:r>
-                        <a:rPr sz="850" b="0" i="0">
+                        <a:rPr sz="760" b="0" i="0">
                           <a:solidFill>
                             <a:srgbClr val="1E2430"/>
                           </a:solidFill>
@@ -9014,7 +9014,7 @@
                     <a:p>
                       <a:pPr algn="l"/>
                       <a:r>
-                        <a:rPr sz="850" b="0" i="0">
+                        <a:rPr sz="760" b="0" i="0">
                           <a:solidFill>
                             <a:srgbClr val="1E2430"/>
                           </a:solidFill>
@@ -9039,7 +9039,7 @@
                     <a:p>
                       <a:pPr algn="ctr"/>
                       <a:r>
-                        <a:rPr sz="850" b="1" i="0">
+                        <a:rPr sz="760" b="1" i="0">
                           <a:solidFill>
                             <a:srgbClr val="217A4B"/>
                           </a:solidFill>
@@ -9058,7 +9058,7 @@
                   </a:tcPr>
                 </a:tc>
               </a:tr>
-              <a:tr h="402336">
+              <a:tr h="356616">
                 <a:tc>
                   <a:txBody>
                     <a:bodyPr/>
@@ -9066,7 +9066,7 @@
                     <a:p>
                       <a:pPr algn="l"/>
                       <a:r>
-                        <a:rPr sz="850" b="1" i="0">
+                        <a:rPr sz="760" b="1" i="0">
                           <a:solidFill>
                             <a:srgbClr val="1E2430"/>
                           </a:solidFill>
@@ -9091,7 +9091,7 @@
                     <a:p>
                       <a:pPr algn="ctr"/>
                       <a:r>
-                        <a:rPr sz="850" b="0" i="0">
+                        <a:rPr sz="760" b="0" i="0">
                           <a:solidFill>
                             <a:srgbClr val="1E2430"/>
                           </a:solidFill>
@@ -9116,7 +9116,7 @@
                     <a:p>
                       <a:pPr algn="l"/>
                       <a:r>
-                        <a:rPr sz="850" b="0" i="0">
+                        <a:rPr sz="760" b="0" i="0">
                           <a:solidFill>
                             <a:srgbClr val="1E2430"/>
                           </a:solidFill>
@@ -9141,7 +9141,7 @@
                     <a:p>
                       <a:pPr algn="ctr"/>
                       <a:r>
-                        <a:rPr sz="850" b="1" i="0">
+                        <a:rPr sz="760" b="1" i="0">
                           <a:solidFill>
                             <a:srgbClr val="217A4B"/>
                           </a:solidFill>
@@ -9160,7 +9160,7 @@
                   </a:tcPr>
                 </a:tc>
               </a:tr>
-              <a:tr h="402336">
+              <a:tr h="356616">
                 <a:tc>
                   <a:txBody>
                     <a:bodyPr/>
@@ -9168,7 +9168,7 @@
                     <a:p>
                       <a:pPr algn="l"/>
                       <a:r>
-                        <a:rPr sz="850" b="1" i="0">
+                        <a:rPr sz="760" b="1" i="0">
                           <a:solidFill>
                             <a:srgbClr val="1E2430"/>
                           </a:solidFill>
@@ -9193,7 +9193,7 @@
                     <a:p>
                       <a:pPr algn="ctr"/>
                       <a:r>
-                        <a:rPr sz="850" b="0" i="0">
+                        <a:rPr sz="760" b="0" i="0">
                           <a:solidFill>
                             <a:srgbClr val="1E2430"/>
                           </a:solidFill>
@@ -9218,7 +9218,7 @@
                     <a:p>
                       <a:pPr algn="l"/>
                       <a:r>
-                        <a:rPr sz="850" b="0" i="0">
+                        <a:rPr sz="760" b="0" i="0">
                           <a:solidFill>
                             <a:srgbClr val="1E2430"/>
                           </a:solidFill>
@@ -9243,7 +9243,7 @@
                     <a:p>
                       <a:pPr algn="ctr"/>
                       <a:r>
-                        <a:rPr sz="850" b="1" i="0">
+                        <a:rPr sz="760" b="1" i="0">
                           <a:solidFill>
                             <a:srgbClr val="217A4B"/>
                           </a:solidFill>
@@ -10307,7 +10307,7 @@
               <a:t>• Đóng gói Two-Tier Solver &amp; 7-Day Planner thành dịch vụ API chuẩn hóa.
 • Endpoint /api/menu/generate: Tiếp nhận UserProfile, sinh 3 options A/B/C.
 • Endpoint /api/menu/swap: Cho phép đổi 1 món ăn cụ thể và tự động cân chỉnh lại gram các món còn lại.
-• Mục tiêu sau tối ưu: hướng tới dưới 1.5 giây/ngày bằng cache, warm start, thu gọn pool và xử lý song song.</a:t>
+• Mục tiêu sau tối ưu: hướng tới dưới 1.5 giây/ngày bằng cache, warm start, thu gọn candidate pool và xử lý song song.</a:t>
             </a:r>
           </a:p>
         </p:txBody>
@@ -17518,7 +17518,7 @@
                 <a:ea typeface="Calibri"/>
                 <a:cs typeface="Calibri"/>
               </a:rPr>
-              <a:t>2. Độ hội tụ ổn định: Mean Fitness đạt 98.2148 với độ lệch chuẩn nhỏ (Std = 1.0663). Cả 20 lượt chạy không ghi nhận vi phạm trong tập ràng buộc kỹ thuật của benchmark tuần 8.</a:t>
+              <a:t>2. Kết quả so sánh: DBO và IDBO cho cùng Best/Mean Fitness trên 10 seed. Trong cấu hình 25 vòng lặp, telemetry cho thấy perturbation/restart chưa kích hoạt đáng kể; vì vậy chưa có bằng chứng IDBO vượt trội hơn DBO trong phạm vi thử nghiệm này.</a:t>
             </a:r>
           </a:p>
         </p:txBody>
@@ -18003,8 +18003,8 @@
                 <a:cs typeface="Calibri"/>
               </a:rPr>
               <a:t>W8-F1: Đường cong hội tụ tầng ngoài (Outer Iterations 1–25)
-• Trong cấu hình 25 vòng lặp, DBO và IDBO cho đường hội tụ và chất lượng nghiệm gần như giống nhau.
-• Cần đối chiếu telemetry perturbation/restart và thử nghiệm dài hơn để đánh giá đóng góp riêng của IDBO.</a:t>
+• DBO và IDBO cho đường hội tụ gần như trùng nhau trong cấu hình 25 vòng lặp.
+• Cơ chế perturbation/restart chưa kích hoạt đáng kể; chưa thể kết luận IDBO tốt hơn DBO.</a:t>
             </a:r>
           </a:p>
         </p:txBody>

</xml_diff>

<commit_message>
fix(slides): fix slide 10 table column widths and card spacing to eliminate overlap
</commit_message>
<xml_diff>
--- a/docs/slides/Slide_Bao_Cao_Tuan_8_9_DBO_IDBO.pptx
+++ b/docs/slides/Slide_Bao_Cao_Tuan_8_9_DBO_IDBO.pptx
@@ -3827,8 +3827,8 @@
           <p:nvPr/>
         </p:nvGraphicFramePr>
         <p:xfrm>
-          <a:off x="502920" y="1234440"/>
-          <a:ext cx="11183112" cy="2798064"/>
+          <a:off x="502920" y="1188720"/>
+          <a:ext cx="11183112" cy="2304288"/>
         </p:xfrm>
         <a:graphic>
           <a:graphicData uri="http://schemas.openxmlformats.org/drawingml/2006/table">
@@ -3837,14 +3837,14 @@
                 <a:tableStyleId>{5C22544A-7EE6-4342-B048-85BDC9FD1C3A}</a:tableStyleId>
               </a:tblPr>
               <a:tblGrid>
+                <a:gridCol w="822960"/>
+                <a:gridCol w="1554480"/>
+                <a:gridCol w="777240"/>
+                <a:gridCol w="1280160"/>
                 <a:gridCol w="1097280"/>
-                <a:gridCol w="2011680"/>
-                <a:gridCol w="914400"/>
-                <a:gridCol w="1645920"/>
-                <a:gridCol w="1463040"/>
+                <a:gridCol w="1005840"/>
                 <a:gridCol w="1188720"/>
-                <a:gridCol w="1371600"/>
-                <a:gridCol w="1490472"/>
+                <a:gridCol w="3456432"/>
               </a:tblGrid>
               <a:tr h="384048">
                 <a:tc>
@@ -4048,7 +4048,7 @@
                   </a:tcPr>
                 </a:tc>
               </a:tr>
-              <a:tr h="402336">
+              <a:tr h="320040">
                 <a:tc>
                   <a:txBody>
                     <a:bodyPr/>
@@ -4056,7 +4056,7 @@
                     <a:p>
                       <a:pPr algn="ctr"/>
                       <a:r>
-                        <a:rPr sz="980" b="1" i="0">
+                        <a:rPr sz="850" b="1" i="0">
                           <a:solidFill>
                             <a:srgbClr val="1E2430"/>
                           </a:solidFill>
@@ -4081,7 +4081,7 @@
                     <a:p>
                       <a:pPr algn="l"/>
                       <a:r>
-                        <a:rPr sz="980" b="0" i="0">
+                        <a:rPr sz="850" b="0" i="0">
                           <a:solidFill>
                             <a:srgbClr val="1E2430"/>
                           </a:solidFill>
@@ -4106,7 +4106,7 @@
                     <a:p>
                       <a:pPr algn="ctr"/>
                       <a:r>
-                        <a:rPr sz="980" b="0" i="0">
+                        <a:rPr sz="850" b="0" i="0">
                           <a:solidFill>
                             <a:srgbClr val="1E2430"/>
                           </a:solidFill>
@@ -4131,7 +4131,7 @@
                     <a:p>
                       <a:pPr algn="ctr"/>
                       <a:r>
-                        <a:rPr sz="980" b="1" i="0">
+                        <a:rPr sz="850" b="1" i="0">
                           <a:solidFill>
                             <a:srgbClr val="217A4B"/>
                           </a:solidFill>
@@ -4156,7 +4156,7 @@
                     <a:p>
                       <a:pPr algn="ctr"/>
                       <a:r>
-                        <a:rPr sz="980" b="0" i="0">
+                        <a:rPr sz="850" b="0" i="0">
                           <a:solidFill>
                             <a:srgbClr val="1E2430"/>
                           </a:solidFill>
@@ -4181,7 +4181,7 @@
                     <a:p>
                       <a:pPr algn="ctr"/>
                       <a:r>
-                        <a:rPr sz="980" b="0" i="0">
+                        <a:rPr sz="850" b="0" i="0">
                           <a:solidFill>
                             <a:srgbClr val="1E2430"/>
                           </a:solidFill>
@@ -4206,7 +4206,7 @@
                     <a:p>
                       <a:pPr algn="ctr"/>
                       <a:r>
-                        <a:rPr sz="980" b="1" i="0">
+                        <a:rPr sz="850" b="1" i="0">
                           <a:solidFill>
                             <a:srgbClr val="217A4B"/>
                           </a:solidFill>
@@ -4231,7 +4231,7 @@
                     <a:p>
                       <a:pPr algn="l"/>
                       <a:r>
-                        <a:rPr sz="980" b="0" i="0">
+                        <a:rPr sz="850" b="0" i="0">
                           <a:solidFill>
                             <a:srgbClr val="1E2430"/>
                           </a:solidFill>
@@ -4250,7 +4250,7 @@
                   </a:tcPr>
                 </a:tc>
               </a:tr>
-              <a:tr h="402336">
+              <a:tr h="320040">
                 <a:tc>
                   <a:txBody>
                     <a:bodyPr/>
@@ -4258,7 +4258,7 @@
                     <a:p>
                       <a:pPr algn="ctr"/>
                       <a:r>
-                        <a:rPr sz="980" b="1" i="0">
+                        <a:rPr sz="850" b="1" i="0">
                           <a:solidFill>
                             <a:srgbClr val="1E2430"/>
                           </a:solidFill>
@@ -4283,7 +4283,7 @@
                     <a:p>
                       <a:pPr algn="l"/>
                       <a:r>
-                        <a:rPr sz="980" b="0" i="0">
+                        <a:rPr sz="850" b="0" i="0">
                           <a:solidFill>
                             <a:srgbClr val="1E2430"/>
                           </a:solidFill>
@@ -4308,7 +4308,7 @@
                     <a:p>
                       <a:pPr algn="ctr"/>
                       <a:r>
-                        <a:rPr sz="980" b="0" i="0">
+                        <a:rPr sz="850" b="0" i="0">
                           <a:solidFill>
                             <a:srgbClr val="1E2430"/>
                           </a:solidFill>
@@ -4333,7 +4333,7 @@
                     <a:p>
                       <a:pPr algn="ctr"/>
                       <a:r>
-                        <a:rPr sz="980" b="1" i="0">
+                        <a:rPr sz="850" b="1" i="0">
                           <a:solidFill>
                             <a:srgbClr val="1B2A4A"/>
                           </a:solidFill>
@@ -4358,7 +4358,7 @@
                     <a:p>
                       <a:pPr algn="ctr"/>
                       <a:r>
-                        <a:rPr sz="980" b="0" i="0">
+                        <a:rPr sz="850" b="0" i="0">
                           <a:solidFill>
                             <a:srgbClr val="1E2430"/>
                           </a:solidFill>
@@ -4383,7 +4383,7 @@
                     <a:p>
                       <a:pPr algn="ctr"/>
                       <a:r>
-                        <a:rPr sz="980" b="0" i="0">
+                        <a:rPr sz="850" b="0" i="0">
                           <a:solidFill>
                             <a:srgbClr val="1E2430"/>
                           </a:solidFill>
@@ -4408,7 +4408,7 @@
                     <a:p>
                       <a:pPr algn="ctr"/>
                       <a:r>
-                        <a:rPr sz="980" b="1" i="0">
+                        <a:rPr sz="850" b="1" i="0">
                           <a:solidFill>
                             <a:srgbClr val="217A4B"/>
                           </a:solidFill>
@@ -4433,7 +4433,7 @@
                     <a:p>
                       <a:pPr algn="l"/>
                       <a:r>
-                        <a:rPr sz="980" b="0" i="0">
+                        <a:rPr sz="850" b="0" i="0">
                           <a:solidFill>
                             <a:srgbClr val="1E2430"/>
                           </a:solidFill>
@@ -4452,7 +4452,7 @@
                   </a:tcPr>
                 </a:tc>
               </a:tr>
-              <a:tr h="402336">
+              <a:tr h="320040">
                 <a:tc>
                   <a:txBody>
                     <a:bodyPr/>
@@ -4460,7 +4460,7 @@
                     <a:p>
                       <a:pPr algn="ctr"/>
                       <a:r>
-                        <a:rPr sz="980" b="1" i="0">
+                        <a:rPr sz="850" b="1" i="0">
                           <a:solidFill>
                             <a:srgbClr val="1E2430"/>
                           </a:solidFill>
@@ -4485,7 +4485,7 @@
                     <a:p>
                       <a:pPr algn="l"/>
                       <a:r>
-                        <a:rPr sz="980" b="0" i="0">
+                        <a:rPr sz="850" b="0" i="0">
                           <a:solidFill>
                             <a:srgbClr val="1E2430"/>
                           </a:solidFill>
@@ -4510,7 +4510,7 @@
                     <a:p>
                       <a:pPr algn="ctr"/>
                       <a:r>
-                        <a:rPr sz="980" b="0" i="0">
+                        <a:rPr sz="850" b="0" i="0">
                           <a:solidFill>
                             <a:srgbClr val="1E2430"/>
                           </a:solidFill>
@@ -4535,7 +4535,7 @@
                     <a:p>
                       <a:pPr algn="ctr"/>
                       <a:r>
-                        <a:rPr sz="980" b="1" i="0">
+                        <a:rPr sz="850" b="1" i="0">
                           <a:solidFill>
                             <a:srgbClr val="217A4B"/>
                           </a:solidFill>
@@ -4560,7 +4560,7 @@
                     <a:p>
                       <a:pPr algn="ctr"/>
                       <a:r>
-                        <a:rPr sz="980" b="0" i="0">
+                        <a:rPr sz="850" b="0" i="0">
                           <a:solidFill>
                             <a:srgbClr val="1E2430"/>
                           </a:solidFill>
@@ -4585,7 +4585,7 @@
                     <a:p>
                       <a:pPr algn="ctr"/>
                       <a:r>
-                        <a:rPr sz="980" b="0" i="0">
+                        <a:rPr sz="850" b="0" i="0">
                           <a:solidFill>
                             <a:srgbClr val="1E2430"/>
                           </a:solidFill>
@@ -4610,7 +4610,7 @@
                     <a:p>
                       <a:pPr algn="ctr"/>
                       <a:r>
-                        <a:rPr sz="980" b="1" i="0">
+                        <a:rPr sz="850" b="1" i="0">
                           <a:solidFill>
                             <a:srgbClr val="217A4B"/>
                           </a:solidFill>
@@ -4635,7 +4635,7 @@
                     <a:p>
                       <a:pPr algn="l"/>
                       <a:r>
-                        <a:rPr sz="980" b="0" i="0">
+                        <a:rPr sz="850" b="0" i="0">
                           <a:solidFill>
                             <a:srgbClr val="1E2430"/>
                           </a:solidFill>
@@ -4654,7 +4654,7 @@
                   </a:tcPr>
                 </a:tc>
               </a:tr>
-              <a:tr h="402336">
+              <a:tr h="320040">
                 <a:tc>
                   <a:txBody>
                     <a:bodyPr/>
@@ -4662,7 +4662,7 @@
                     <a:p>
                       <a:pPr algn="ctr"/>
                       <a:r>
-                        <a:rPr sz="980" b="1" i="0">
+                        <a:rPr sz="850" b="1" i="0">
                           <a:solidFill>
                             <a:srgbClr val="1E2430"/>
                           </a:solidFill>
@@ -4687,7 +4687,7 @@
                     <a:p>
                       <a:pPr algn="l"/>
                       <a:r>
-                        <a:rPr sz="980" b="0" i="0">
+                        <a:rPr sz="850" b="0" i="0">
                           <a:solidFill>
                             <a:srgbClr val="1E2430"/>
                           </a:solidFill>
@@ -4712,7 +4712,7 @@
                     <a:p>
                       <a:pPr algn="ctr"/>
                       <a:r>
-                        <a:rPr sz="980" b="0" i="0">
+                        <a:rPr sz="850" b="0" i="0">
                           <a:solidFill>
                             <a:srgbClr val="1E2430"/>
                           </a:solidFill>
@@ -4737,7 +4737,7 @@
                     <a:p>
                       <a:pPr algn="ctr"/>
                       <a:r>
-                        <a:rPr sz="980" b="0" i="0">
+                        <a:rPr sz="850" b="0" i="0">
                           <a:solidFill>
                             <a:srgbClr val="1E2430"/>
                           </a:solidFill>
@@ -4762,7 +4762,7 @@
                     <a:p>
                       <a:pPr algn="ctr"/>
                       <a:r>
-                        <a:rPr sz="980" b="0" i="0">
+                        <a:rPr sz="850" b="0" i="0">
                           <a:solidFill>
                             <a:srgbClr val="1E2430"/>
                           </a:solidFill>
@@ -4787,7 +4787,7 @@
                     <a:p>
                       <a:pPr algn="ctr"/>
                       <a:r>
-                        <a:rPr sz="980" b="0" i="0">
+                        <a:rPr sz="850" b="0" i="0">
                           <a:solidFill>
                             <a:srgbClr val="1E2430"/>
                           </a:solidFill>
@@ -4812,7 +4812,7 @@
                     <a:p>
                       <a:pPr algn="ctr"/>
                       <a:r>
-                        <a:rPr sz="980" b="0" i="0">
+                        <a:rPr sz="850" b="0" i="0">
                           <a:solidFill>
                             <a:srgbClr val="1E2430"/>
                           </a:solidFill>
@@ -4837,7 +4837,7 @@
                     <a:p>
                       <a:pPr algn="l"/>
                       <a:r>
-                        <a:rPr sz="980" b="0" i="0">
+                        <a:rPr sz="850" b="0" i="0">
                           <a:solidFill>
                             <a:srgbClr val="1E2430"/>
                           </a:solidFill>
@@ -4856,7 +4856,7 @@
                   </a:tcPr>
                 </a:tc>
               </a:tr>
-              <a:tr h="402336">
+              <a:tr h="320040">
                 <a:tc>
                   <a:txBody>
                     <a:bodyPr/>
@@ -4864,7 +4864,7 @@
                     <a:p>
                       <a:pPr algn="ctr"/>
                       <a:r>
-                        <a:rPr sz="980" b="1" i="0">
+                        <a:rPr sz="850" b="1" i="0">
                           <a:solidFill>
                             <a:srgbClr val="1E2430"/>
                           </a:solidFill>
@@ -4889,7 +4889,7 @@
                     <a:p>
                       <a:pPr algn="l"/>
                       <a:r>
-                        <a:rPr sz="980" b="0" i="0">
+                        <a:rPr sz="850" b="0" i="0">
                           <a:solidFill>
                             <a:srgbClr val="1E2430"/>
                           </a:solidFill>
@@ -4914,7 +4914,7 @@
                     <a:p>
                       <a:pPr algn="ctr"/>
                       <a:r>
-                        <a:rPr sz="980" b="0" i="0">
+                        <a:rPr sz="850" b="0" i="0">
                           <a:solidFill>
                             <a:srgbClr val="1E2430"/>
                           </a:solidFill>
@@ -4939,7 +4939,7 @@
                     <a:p>
                       <a:pPr algn="ctr"/>
                       <a:r>
-                        <a:rPr sz="980" b="0" i="0">
+                        <a:rPr sz="850" b="0" i="0">
                           <a:solidFill>
                             <a:srgbClr val="1E2430"/>
                           </a:solidFill>
@@ -4964,7 +4964,7 @@
                     <a:p>
                       <a:pPr algn="ctr"/>
                       <a:r>
-                        <a:rPr sz="980" b="0" i="0">
+                        <a:rPr sz="850" b="0" i="0">
                           <a:solidFill>
                             <a:srgbClr val="1E2430"/>
                           </a:solidFill>
@@ -4989,7 +4989,7 @@
                     <a:p>
                       <a:pPr algn="ctr"/>
                       <a:r>
-                        <a:rPr sz="980" b="0" i="0">
+                        <a:rPr sz="850" b="0" i="0">
                           <a:solidFill>
                             <a:srgbClr val="1E2430"/>
                           </a:solidFill>
@@ -5014,7 +5014,7 @@
                     <a:p>
                       <a:pPr algn="ctr"/>
                       <a:r>
-                        <a:rPr sz="980" b="0" i="0">
+                        <a:rPr sz="850" b="0" i="0">
                           <a:solidFill>
                             <a:srgbClr val="1E2430"/>
                           </a:solidFill>
@@ -5039,7 +5039,7 @@
                     <a:p>
                       <a:pPr algn="l"/>
                       <a:r>
-                        <a:rPr sz="980" b="0" i="0">
+                        <a:rPr sz="850" b="0" i="0">
                           <a:solidFill>
                             <a:srgbClr val="1E2430"/>
                           </a:solidFill>
@@ -5058,7 +5058,7 @@
                   </a:tcPr>
                 </a:tc>
               </a:tr>
-              <a:tr h="402336">
+              <a:tr h="320040">
                 <a:tc>
                   <a:txBody>
                     <a:bodyPr/>
@@ -5066,7 +5066,7 @@
                     <a:p>
                       <a:pPr algn="ctr"/>
                       <a:r>
-                        <a:rPr sz="980" b="1" i="0">
+                        <a:rPr sz="850" b="1" i="0">
                           <a:solidFill>
                             <a:srgbClr val="1E2430"/>
                           </a:solidFill>
@@ -5091,7 +5091,7 @@
                     <a:p>
                       <a:pPr algn="l"/>
                       <a:r>
-                        <a:rPr sz="980" b="0" i="0">
+                        <a:rPr sz="850" b="0" i="0">
                           <a:solidFill>
                             <a:srgbClr val="1E2430"/>
                           </a:solidFill>
@@ -5116,7 +5116,7 @@
                     <a:p>
                       <a:pPr algn="ctr"/>
                       <a:r>
-                        <a:rPr sz="980" b="0" i="0">
+                        <a:rPr sz="850" b="0" i="0">
                           <a:solidFill>
                             <a:srgbClr val="1E2430"/>
                           </a:solidFill>
@@ -5141,7 +5141,7 @@
                     <a:p>
                       <a:pPr algn="ctr"/>
                       <a:r>
-                        <a:rPr sz="980" b="0" i="0">
+                        <a:rPr sz="850" b="0" i="0">
                           <a:solidFill>
                             <a:srgbClr val="1E2430"/>
                           </a:solidFill>
@@ -5166,7 +5166,7 @@
                     <a:p>
                       <a:pPr algn="ctr"/>
                       <a:r>
-                        <a:rPr sz="980" b="0" i="0">
+                        <a:rPr sz="850" b="0" i="0">
                           <a:solidFill>
                             <a:srgbClr val="1E2430"/>
                           </a:solidFill>
@@ -5191,7 +5191,7 @@
                     <a:p>
                       <a:pPr algn="ctr"/>
                       <a:r>
-                        <a:rPr sz="980" b="0" i="0">
+                        <a:rPr sz="850" b="0" i="0">
                           <a:solidFill>
                             <a:srgbClr val="1E2430"/>
                           </a:solidFill>
@@ -5216,7 +5216,7 @@
                     <a:p>
                       <a:pPr algn="ctr"/>
                       <a:r>
-                        <a:rPr sz="980" b="0" i="0">
+                        <a:rPr sz="850" b="0" i="0">
                           <a:solidFill>
                             <a:srgbClr val="1E2430"/>
                           </a:solidFill>
@@ -5241,7 +5241,7 @@
                     <a:p>
                       <a:pPr algn="l"/>
                       <a:r>
-                        <a:rPr sz="980" b="0" i="0">
+                        <a:rPr sz="850" b="0" i="0">
                           <a:solidFill>
                             <a:srgbClr val="1E2430"/>
                           </a:solidFill>
@@ -5272,8 +5272,8 @@
         </p:nvSpPr>
         <p:spPr>
           <a:xfrm>
-            <a:off x="502920" y="4343400"/>
-            <a:ext cx="3593592" cy="1965960"/>
+            <a:off x="502920" y="3794760"/>
+            <a:ext cx="3593592" cy="2423160"/>
           </a:xfrm>
           <a:prstGeom prst="roundRect">
             <a:avLst/>
@@ -5318,7 +5318,7 @@
         </p:nvSpPr>
         <p:spPr>
           <a:xfrm>
-            <a:off x="685800" y="4462272"/>
+            <a:off x="685800" y="3904487"/>
             <a:ext cx="3227832" cy="256032"/>
           </a:xfrm>
           <a:prstGeom prst="rect">
@@ -5362,7 +5362,7 @@
         </p:nvSpPr>
         <p:spPr>
           <a:xfrm>
-            <a:off x="685800" y="4736592"/>
+            <a:off x="685800" y="4178808"/>
             <a:ext cx="3227832" cy="12700"/>
           </a:xfrm>
           <a:prstGeom prst="rect">
@@ -5406,8 +5406,8 @@
         </p:nvSpPr>
         <p:spPr>
           <a:xfrm>
-            <a:off x="685800" y="4828032"/>
-            <a:ext cx="3227832" cy="1371600"/>
+            <a:off x="685800" y="4279392"/>
+            <a:ext cx="3227832" cy="1828800"/>
           </a:xfrm>
           <a:prstGeom prst="rect">
             <a:avLst/>
@@ -5422,14 +5422,14 @@
           <a:p>
             <a:pPr algn="l">
               <a:lnSpc>
-                <a:spcPct val="120000"/>
+                <a:spcPct val="118000"/>
               </a:lnSpc>
               <a:spcAft>
                 <a:spcPts val="0"/>
               </a:spcAft>
             </a:pPr>
             <a:r>
-              <a:rPr sz="980" b="0" i="0">
+              <a:rPr sz="919" b="0" i="0">
                 <a:solidFill>
                   <a:srgbClr val="1E2430"/>
                 </a:solidFill>
@@ -5450,8 +5450,8 @@
         </p:nvSpPr>
         <p:spPr>
           <a:xfrm>
-            <a:off x="4297680" y="4343400"/>
-            <a:ext cx="3593592" cy="1965960"/>
+            <a:off x="4297680" y="3794760"/>
+            <a:ext cx="3593592" cy="2423160"/>
           </a:xfrm>
           <a:prstGeom prst="roundRect">
             <a:avLst/>
@@ -5496,7 +5496,7 @@
         </p:nvSpPr>
         <p:spPr>
           <a:xfrm>
-            <a:off x="4480560" y="4462272"/>
+            <a:off x="4480560" y="3904487"/>
             <a:ext cx="3227832" cy="256032"/>
           </a:xfrm>
           <a:prstGeom prst="rect">
@@ -5540,7 +5540,7 @@
         </p:nvSpPr>
         <p:spPr>
           <a:xfrm>
-            <a:off x="4480560" y="4736592"/>
+            <a:off x="4480560" y="4178808"/>
             <a:ext cx="3227832" cy="12700"/>
           </a:xfrm>
           <a:prstGeom prst="rect">
@@ -5584,8 +5584,8 @@
         </p:nvSpPr>
         <p:spPr>
           <a:xfrm>
-            <a:off x="4480560" y="4828032"/>
-            <a:ext cx="3227832" cy="1371600"/>
+            <a:off x="4480560" y="4279392"/>
+            <a:ext cx="3227832" cy="1828800"/>
           </a:xfrm>
           <a:prstGeom prst="rect">
             <a:avLst/>
@@ -5600,14 +5600,14 @@
           <a:p>
             <a:pPr algn="l">
               <a:lnSpc>
-                <a:spcPct val="120000"/>
+                <a:spcPct val="118000"/>
               </a:lnSpc>
               <a:spcAft>
                 <a:spcPts val="0"/>
               </a:spcAft>
             </a:pPr>
             <a:r>
-              <a:rPr sz="980" b="0" i="0">
+              <a:rPr sz="919" b="0" i="0">
                 <a:solidFill>
                   <a:srgbClr val="1E2430"/>
                 </a:solidFill>
@@ -5628,8 +5628,8 @@
         </p:nvSpPr>
         <p:spPr>
           <a:xfrm>
-            <a:off x="8092440" y="4343400"/>
-            <a:ext cx="3593592" cy="1965960"/>
+            <a:off x="8092440" y="3794760"/>
+            <a:ext cx="3593592" cy="2423160"/>
           </a:xfrm>
           <a:prstGeom prst="roundRect">
             <a:avLst/>
@@ -5674,7 +5674,7 @@
         </p:nvSpPr>
         <p:spPr>
           <a:xfrm>
-            <a:off x="8275320" y="4462272"/>
+            <a:off x="8275320" y="3904487"/>
             <a:ext cx="3227832" cy="256032"/>
           </a:xfrm>
           <a:prstGeom prst="rect">
@@ -5718,7 +5718,7 @@
         </p:nvSpPr>
         <p:spPr>
           <a:xfrm>
-            <a:off x="8275320" y="4736592"/>
+            <a:off x="8275320" y="4178808"/>
             <a:ext cx="3227832" cy="12700"/>
           </a:xfrm>
           <a:prstGeom prst="rect">
@@ -5762,8 +5762,8 @@
         </p:nvSpPr>
         <p:spPr>
           <a:xfrm>
-            <a:off x="8275320" y="4828032"/>
-            <a:ext cx="3227832" cy="1371600"/>
+            <a:off x="8275320" y="4279392"/>
+            <a:ext cx="3227832" cy="1828800"/>
           </a:xfrm>
           <a:prstGeom prst="rect">
             <a:avLst/>
@@ -5778,14 +5778,14 @@
           <a:p>
             <a:pPr algn="l">
               <a:lnSpc>
-                <a:spcPct val="120000"/>
+                <a:spcPct val="118000"/>
               </a:lnSpc>
               <a:spcAft>
                 <a:spcPts val="0"/>
               </a:spcAft>
             </a:pPr>
             <a:r>
-              <a:rPr sz="980" b="0" i="0">
+              <a:rPr sz="919" b="0" i="0">
                 <a:solidFill>
                   <a:srgbClr val="1E2430"/>
                 </a:solidFill>

</xml_diff>

<commit_message>
docs: update week 8-9 slides with ablation findings
</commit_message>
<xml_diff>
--- a/docs/slides/Slide_Bao_Cao_Tuan_8_9_DBO_IDBO.pptx
+++ b/docs/slides/Slide_Bao_Cao_Tuan_8_9_DBO_IDBO.pptx
@@ -3619,7 +3619,7 @@
                 <a:ea typeface="Calibri"/>
                 <a:cs typeface="Calibri"/>
               </a:rPr>
-              <a:t>Thời gian báo cáo: Tuần 8–9 (Tháng 10/2026) · 202/202 Unit Tests PASS · CSDL 15.929 món tích hợp</a:t>
+              <a:t>Thời gian báo cáo: Tuần 8–9 (Tháng 10/2026) · 205/205 Unit Tests PASS · CSDL 15.929 món tích hợp</a:t>
             </a:r>
           </a:p>
         </p:txBody>
@@ -8093,7 +8093,7 @@
                 <a:ea typeface="Calibri"/>
                 <a:cs typeface="Calibri"/>
               </a:rPr>
-              <a:t>Đảm Bảo Chất Lượng Phần Mềm (202/202 Tests PASS) &amp; Phân Công</a:t>
+              <a:t>Đảm Bảo Chất Lượng Phần Mềm (205/205 Tests PASS) &amp; Phân Công</a:t>
             </a:r>
           </a:p>
         </p:txBody>
@@ -8271,7 +8271,7 @@
                 <a:ea typeface="Calibri"/>
                 <a:cs typeface="Calibri"/>
               </a:rPr>
-              <a:t>HỆ THỐNG KIỂM THỬ TỰ ĐỘNG: 202/202 TESTS PASS (100%)</a:t>
+              <a:t>HỆ THỐNG KIỂM THỬ TỰ ĐỘNG: 205/205 TESTS PASS (100%)</a:t>
             </a:r>
           </a:p>
         </p:txBody>
@@ -8487,7 +8487,7 @@
                           <a:ea typeface="Calibri"/>
                           <a:cs typeface="Calibri"/>
                         </a:rPr>
-                        <a:t>12 tests</a:t>
+                        <a:t>15 tests</a:t>
                       </a:r>
                     </a:p>
                   </a:txBody>
@@ -8512,7 +8512,7 @@
                           <a:ea typeface="Calibri"/>
                           <a:cs typeface="Calibri"/>
                         </a:rPr>
-                        <a:t>Tối ưu 2 tầng Outer/Inner, cấu hình seed, bounds</a:t>
+                        <a:t>Tối ưu 2 tầng Outer/Inner, IDBO telemetry, bounds</a:t>
                       </a:r>
                     </a:p>
                   </a:txBody>
@@ -9800,7 +9800,7 @@
                 <a:ea typeface="Calibri"/>
                 <a:cs typeface="Calibri"/>
               </a:rPr>
-              <a:t>Kết quả kiểm thử tự động 202/202 tests PASS và phân công trách nhiệm thành viên</a:t>
+              <a:t>Kết quả kiểm thử tự động 205/205 tests PASS và phân công trách nhiệm thành viên</a:t>
             </a:r>
           </a:p>
         </p:txBody>
@@ -17354,7 +17354,7 @@
         <p:spPr>
           <a:xfrm>
             <a:off x="502920" y="4160520"/>
-            <a:ext cx="11183112" cy="2057400"/>
+            <a:ext cx="5440680" cy="2057400"/>
           </a:xfrm>
           <a:prstGeom prst="roundRect">
             <a:avLst/>
@@ -17393,14 +17393,58 @@
       </p:sp>
       <p:sp>
         <p:nvSpPr>
-          <p:cNvPr id="28" name="TextBox 27"/>
+          <p:cNvPr id="28" name="Rectangle 27"/>
+          <p:cNvSpPr/>
+          <p:nvPr/>
+        </p:nvSpPr>
+        <p:spPr>
+          <a:xfrm>
+            <a:off x="502920" y="4160520"/>
+            <a:ext cx="73152" cy="2057400"/>
+          </a:xfrm>
+          <a:prstGeom prst="rect">
+            <a:avLst/>
+          </a:prstGeom>
+          <a:solidFill>
+            <a:srgbClr val="1B2A4A"/>
+          </a:solidFill>
+          <a:ln>
+            <a:noFill/>
+          </a:ln>
+          <a:effectLst/>
+        </p:spPr>
+        <p:style>
+          <a:lnRef idx="1">
+            <a:schemeClr val="accent1"/>
+          </a:lnRef>
+          <a:fillRef idx="3">
+            <a:schemeClr val="accent1"/>
+          </a:fillRef>
+          <a:effectRef idx="2">
+            <a:schemeClr val="accent1"/>
+          </a:effectRef>
+          <a:fontRef idx="minor">
+            <a:schemeClr val="lt1"/>
+          </a:fontRef>
+        </p:style>
+        <p:txBody>
+          <a:bodyPr rtlCol="0" anchor="ctr"/>
+          <a:lstStyle/>
+          <a:p>
+            <a:pPr algn="ctr"/>
+          </a:p>
+        </p:txBody>
+      </p:sp>
+      <p:sp>
+        <p:nvSpPr>
+          <p:cNvPr id="29" name="TextBox 28"/>
           <p:cNvSpPr txBox="1"/>
           <p:nvPr/>
         </p:nvSpPr>
         <p:spPr>
           <a:xfrm>
-            <a:off x="731520" y="4279392"/>
-            <a:ext cx="10698480" cy="274320"/>
+            <a:off x="685800" y="4279392"/>
+            <a:ext cx="5120640" cy="256032"/>
           </a:xfrm>
           <a:prstGeom prst="rect">
             <a:avLst/>
@@ -17422,7 +17466,7 @@
               </a:spcAft>
             </a:pPr>
             <a:r>
-              <a:rPr sz="1150" b="1" i="0">
+              <a:rPr sz="1050" b="1" i="0">
                 <a:solidFill>
                   <a:srgbClr val="1B2A4A"/>
                 </a:solidFill>
@@ -17430,21 +17474,21 @@
                 <a:ea typeface="Calibri"/>
                 <a:cs typeface="Calibri"/>
               </a:rPr>
-              <a:t>PHÂN TÍCH KẾT QUẢ THỰC NGHIỆM ĐỐI CHUẨN TUẦN 8 (10 RUNS ĐỘC LẬP):</a:t>
-            </a:r>
-          </a:p>
-        </p:txBody>
-      </p:sp>
-      <p:sp>
-        <p:nvSpPr>
-          <p:cNvPr id="29" name="TextBox 28"/>
+              <a:t>PHÂN TÍCH ĐỐI CHUẨN TUẦN 8 (10 RUNS ĐỘC LẬP):</a:t>
+            </a:r>
+          </a:p>
+        </p:txBody>
+      </p:sp>
+      <p:sp>
+        <p:nvSpPr>
+          <p:cNvPr id="30" name="TextBox 29"/>
           <p:cNvSpPr txBox="1"/>
           <p:nvPr/>
         </p:nvSpPr>
         <p:spPr>
           <a:xfrm>
-            <a:off x="731520" y="4617720"/>
-            <a:ext cx="10698480" cy="438912"/>
+            <a:off x="685800" y="4590288"/>
+            <a:ext cx="5120640" cy="457200"/>
           </a:xfrm>
           <a:prstGeom prst="rect">
             <a:avLst/>
@@ -17459,14 +17503,14 @@
           <a:p>
             <a:pPr algn="l">
               <a:lnSpc>
-                <a:spcPct val="115000"/>
+                <a:spcPct val="112000"/>
               </a:lnSpc>
               <a:spcAft>
                 <a:spcPts val="0"/>
               </a:spcAft>
             </a:pPr>
             <a:r>
-              <a:rPr sz="1019" b="0" i="0">
+              <a:rPr sz="919" b="0" i="0">
                 <a:solidFill>
                   <a:srgbClr val="1E2430"/>
                 </a:solidFill>
@@ -17474,21 +17518,21 @@
                 <a:ea typeface="Calibri"/>
                 <a:cs typeface="Calibri"/>
               </a:rPr>
-              <a:t>1. Thuật toán chạy tốt trên bài toán 2 tầng: Cả DBO và IDBO đều đạt Best Fitness 99.5106 / 100 tại seed 8003, với mức lệch calo thực đơn 8.1 kcal (0.32% so với mục tiêu 2491.6 kcal của Duy).</a:t>
-            </a:r>
-          </a:p>
-        </p:txBody>
-      </p:sp>
-      <p:sp>
-        <p:nvSpPr>
-          <p:cNvPr id="30" name="TextBox 29"/>
+              <a:t>• Hiệu năng 2 tầng: Cả DBO và IDBO đạt Best Fitness 99.5106 tại seed 8003; mức lệch calo 8.1 kcal (0.32% so với mục tiêu 2491.6 kcal của Duy).</a:t>
+            </a:r>
+          </a:p>
+        </p:txBody>
+      </p:sp>
+      <p:sp>
+        <p:nvSpPr>
+          <p:cNvPr id="31" name="TextBox 30"/>
           <p:cNvSpPr txBox="1"/>
           <p:nvPr/>
         </p:nvSpPr>
         <p:spPr>
           <a:xfrm>
-            <a:off x="731520" y="5093208"/>
-            <a:ext cx="10698480" cy="438912"/>
+            <a:off x="685800" y="5084064"/>
+            <a:ext cx="5120640" cy="457200"/>
           </a:xfrm>
           <a:prstGeom prst="rect">
             <a:avLst/>
@@ -17503,14 +17547,14 @@
           <a:p>
             <a:pPr algn="l">
               <a:lnSpc>
-                <a:spcPct val="115000"/>
+                <a:spcPct val="112000"/>
               </a:lnSpc>
               <a:spcAft>
                 <a:spcPts val="0"/>
               </a:spcAft>
             </a:pPr>
             <a:r>
-              <a:rPr sz="1019" b="0" i="0">
+              <a:rPr sz="919" b="0" i="0">
                 <a:solidFill>
                   <a:srgbClr val="1E2430"/>
                 </a:solidFill>
@@ -17518,21 +17562,21 @@
                 <a:ea typeface="Calibri"/>
                 <a:cs typeface="Calibri"/>
               </a:rPr>
-              <a:t>2. Kết quả so sánh: DBO và IDBO cho cùng Best/Mean Fitness trên 10 seed. Trong cấu hình 25 vòng lặp, telemetry cho thấy perturbation/restart chưa kích hoạt đáng kể; vì vậy chưa có bằng chứng IDBO vượt trội hơn DBO trong phạm vi thử nghiệm này.</a:t>
-            </a:r>
-          </a:p>
-        </p:txBody>
-      </p:sp>
-      <p:sp>
-        <p:nvSpPr>
-          <p:cNvPr id="31" name="TextBox 30"/>
+              <a:t>• Chi phí tính toán: ~210 lần tầng Outer, ~54.800 lần tầng Inner; thời gian 7.6s–8.2s (cần tối ưu cache/xử lý nền khi tích hợp API thực tế).</a:t>
+            </a:r>
+          </a:p>
+        </p:txBody>
+      </p:sp>
+      <p:sp>
+        <p:nvSpPr>
+          <p:cNvPr id="32" name="TextBox 31"/>
           <p:cNvSpPr txBox="1"/>
           <p:nvPr/>
         </p:nvSpPr>
         <p:spPr>
           <a:xfrm>
-            <a:off x="731520" y="5568696"/>
-            <a:ext cx="10698480" cy="438912"/>
+            <a:off x="685800" y="5577840"/>
+            <a:ext cx="5120640" cy="457200"/>
           </a:xfrm>
           <a:prstGeom prst="rect">
             <a:avLst/>
@@ -17547,14 +17591,14 @@
           <a:p>
             <a:pPr algn="l">
               <a:lnSpc>
-                <a:spcPct val="115000"/>
+                <a:spcPct val="112000"/>
               </a:lnSpc>
               <a:spcAft>
                 <a:spcPts val="0"/>
               </a:spcAft>
             </a:pPr>
             <a:r>
-              <a:rPr sz="1019" b="0" i="0">
+              <a:rPr sz="919" b="0" i="0">
                 <a:solidFill>
                   <a:srgbClr val="1E2430"/>
                 </a:solidFill>
@@ -17562,14 +17606,324 @@
                 <a:ea typeface="Calibri"/>
                 <a:cs typeface="Calibri"/>
               </a:rPr>
-              <a:t>3. Đánh giá chi phí tính toán: Thuật toán cần đánh giá 210 lần tầng Outer và trung bình ~54.800 lần tầng Inner. Thời gian 7.60s – 8.25s cho thấy cần tiếp tục tối ưu, cache hoặc xử lý nền trước khi tích hợp Web/API thời gian thực.</a:t>
-            </a:r>
-          </a:p>
-        </p:txBody>
-      </p:sp>
-      <p:sp>
-        <p:nvSpPr>
-          <p:cNvPr id="32" name="Rectangle 31"/>
+              <a:t>• Tính hợp lệ: 100% lượt chạy đạt 0 vi phạm ràng buộc kỹ thuật; DBO và IDBO cho kết quả đồng nhất trên toàn bộ 10 seed.</a:t>
+            </a:r>
+          </a:p>
+        </p:txBody>
+      </p:sp>
+      <p:sp>
+        <p:nvSpPr>
+          <p:cNvPr id="33" name="Rounded Rectangle 32"/>
+          <p:cNvSpPr/>
+          <p:nvPr/>
+        </p:nvSpPr>
+        <p:spPr>
+          <a:xfrm>
+            <a:off x="6245352" y="4160520"/>
+            <a:ext cx="5440680" cy="2057400"/>
+          </a:xfrm>
+          <a:prstGeom prst="roundRect">
+            <a:avLst/>
+          </a:prstGeom>
+          <a:solidFill>
+            <a:srgbClr val="F5F7FB"/>
+          </a:solidFill>
+          <a:ln w="12700">
+            <a:solidFill>
+              <a:srgbClr val="D3DBEA"/>
+            </a:solidFill>
+          </a:ln>
+          <a:effectLst/>
+        </p:spPr>
+        <p:style>
+          <a:lnRef idx="1">
+            <a:schemeClr val="accent1"/>
+          </a:lnRef>
+          <a:fillRef idx="3">
+            <a:schemeClr val="accent1"/>
+          </a:fillRef>
+          <a:effectRef idx="2">
+            <a:schemeClr val="accent1"/>
+          </a:effectRef>
+          <a:fontRef idx="minor">
+            <a:schemeClr val="lt1"/>
+          </a:fontRef>
+        </p:style>
+        <p:txBody>
+          <a:bodyPr rtlCol="0" anchor="ctr"/>
+          <a:lstStyle/>
+          <a:p>
+            <a:pPr algn="ctr"/>
+          </a:p>
+        </p:txBody>
+      </p:sp>
+      <p:sp>
+        <p:nvSpPr>
+          <p:cNvPr id="34" name="Rectangle 33"/>
+          <p:cNvSpPr/>
+          <p:nvPr/>
+        </p:nvSpPr>
+        <p:spPr>
+          <a:xfrm>
+            <a:off x="6245352" y="4160520"/>
+            <a:ext cx="73152" cy="2057400"/>
+          </a:xfrm>
+          <a:prstGeom prst="rect">
+            <a:avLst/>
+          </a:prstGeom>
+          <a:solidFill>
+            <a:srgbClr val="D9822B"/>
+          </a:solidFill>
+          <a:ln>
+            <a:noFill/>
+          </a:ln>
+          <a:effectLst/>
+        </p:spPr>
+        <p:style>
+          <a:lnRef idx="1">
+            <a:schemeClr val="accent1"/>
+          </a:lnRef>
+          <a:fillRef idx="3">
+            <a:schemeClr val="accent1"/>
+          </a:fillRef>
+          <a:effectRef idx="2">
+            <a:schemeClr val="accent1"/>
+          </a:effectRef>
+          <a:fontRef idx="minor">
+            <a:schemeClr val="lt1"/>
+          </a:fontRef>
+        </p:style>
+        <p:txBody>
+          <a:bodyPr rtlCol="0" anchor="ctr"/>
+          <a:lstStyle/>
+          <a:p>
+            <a:pPr algn="ctr"/>
+          </a:p>
+        </p:txBody>
+      </p:sp>
+      <p:sp>
+        <p:nvSpPr>
+          <p:cNvPr id="35" name="TextBox 34"/>
+          <p:cNvSpPr txBox="1"/>
+          <p:nvPr/>
+        </p:nvSpPr>
+        <p:spPr>
+          <a:xfrm>
+            <a:off x="6428232" y="4279392"/>
+            <a:ext cx="5120640" cy="256032"/>
+          </a:xfrm>
+          <a:prstGeom prst="rect">
+            <a:avLst/>
+          </a:prstGeom>
+          <a:noFill/>
+        </p:spPr>
+        <p:txBody>
+          <a:bodyPr wrap="square" anchor="t" lIns="0" rIns="0" tIns="0" bIns="0">
+            <a:spAutoFit/>
+          </a:bodyPr>
+          <a:lstStyle/>
+          <a:p>
+            <a:pPr algn="l">
+              <a:lnSpc>
+                <a:spcPct val="100000"/>
+              </a:lnSpc>
+              <a:spcAft>
+                <a:spcPts val="0"/>
+              </a:spcAft>
+            </a:pPr>
+            <a:r>
+              <a:rPr sz="1050" b="1" i="0">
+                <a:solidFill>
+                  <a:srgbClr val="D9822B"/>
+                </a:solidFill>
+                <a:latin typeface="Calibri"/>
+                <a:ea typeface="Calibri"/>
+                <a:cs typeface="Calibri"/>
+              </a:rPr>
+              <a:t>KIỂM TRA KÍCH HOẠT CƠ CHẾ IDBO (ABLATION DIAGNOSTIC):</a:t>
+            </a:r>
+          </a:p>
+        </p:txBody>
+      </p:sp>
+      <p:sp>
+        <p:nvSpPr>
+          <p:cNvPr id="36" name="TextBox 35"/>
+          <p:cNvSpPr txBox="1"/>
+          <p:nvPr/>
+        </p:nvSpPr>
+        <p:spPr>
+          <a:xfrm>
+            <a:off x="6428232" y="4590288"/>
+            <a:ext cx="5120640" cy="365760"/>
+          </a:xfrm>
+          <a:prstGeom prst="rect">
+            <a:avLst/>
+          </a:prstGeom>
+          <a:noFill/>
+        </p:spPr>
+        <p:txBody>
+          <a:bodyPr wrap="square" anchor="t" lIns="0" rIns="0" tIns="0" bIns="0">
+            <a:spAutoFit/>
+          </a:bodyPr>
+          <a:lstStyle/>
+          <a:p>
+            <a:pPr algn="l">
+              <a:lnSpc>
+                <a:spcPct val="110000"/>
+              </a:lnSpc>
+              <a:spcAft>
+                <a:spcPts val="0"/>
+              </a:spcAft>
+            </a:pPr>
+            <a:r>
+              <a:rPr sz="880" b="0" i="0">
+                <a:solidFill>
+                  <a:srgbClr val="1E2430"/>
+                </a:solidFill>
+                <a:latin typeface="Calibri"/>
+                <a:ea typeface="Calibri"/>
+                <a:cs typeface="Calibri"/>
+              </a:rPr>
+              <a:t>• Baseline 25 vòng: DBO Mean 98.2148 | IDBO Mean 98.2148 | Perturbations: 0 | Restarts: 0</a:t>
+            </a:r>
+          </a:p>
+        </p:txBody>
+      </p:sp>
+      <p:sp>
+        <p:nvSpPr>
+          <p:cNvPr id="37" name="TextBox 36"/>
+          <p:cNvSpPr txBox="1"/>
+          <p:nvPr/>
+        </p:nvSpPr>
+        <p:spPr>
+          <a:xfrm>
+            <a:off x="6428232" y="4974336"/>
+            <a:ext cx="5120640" cy="365760"/>
+          </a:xfrm>
+          <a:prstGeom prst="rect">
+            <a:avLst/>
+          </a:prstGeom>
+          <a:noFill/>
+        </p:spPr>
+        <p:txBody>
+          <a:bodyPr wrap="square" anchor="t" lIns="0" rIns="0" tIns="0" bIns="0">
+            <a:spAutoFit/>
+          </a:bodyPr>
+          <a:lstStyle/>
+          <a:p>
+            <a:pPr algn="l">
+              <a:lnSpc>
+                <a:spcPct val="110000"/>
+              </a:lnSpc>
+              <a:spcAft>
+                <a:spcPts val="0"/>
+              </a:spcAft>
+            </a:pPr>
+            <a:r>
+              <a:rPr sz="880" b="0" i="0">
+                <a:solidFill>
+                  <a:srgbClr val="1E2430"/>
+                </a:solidFill>
+                <a:latin typeface="Calibri"/>
+                <a:ea typeface="Calibri"/>
+                <a:cs typeface="Calibri"/>
+              </a:rPr>
+              <a:t>• Chẩn đoán 100 vòng: DBO Mean 97.9821 | IDBO Mean 97.9821 | Perturbations: 0 | Restarts: 0</a:t>
+            </a:r>
+          </a:p>
+        </p:txBody>
+      </p:sp>
+      <p:sp>
+        <p:nvSpPr>
+          <p:cNvPr id="38" name="TextBox 37"/>
+          <p:cNvSpPr txBox="1"/>
+          <p:nvPr/>
+        </p:nvSpPr>
+        <p:spPr>
+          <a:xfrm>
+            <a:off x="6428232" y="5358383"/>
+            <a:ext cx="5120640" cy="365760"/>
+          </a:xfrm>
+          <a:prstGeom prst="rect">
+            <a:avLst/>
+          </a:prstGeom>
+          <a:noFill/>
+        </p:spPr>
+        <p:txBody>
+          <a:bodyPr wrap="square" anchor="t" lIns="0" rIns="0" tIns="0" bIns="0">
+            <a:spAutoFit/>
+          </a:bodyPr>
+          <a:lstStyle/>
+          <a:p>
+            <a:pPr algn="l">
+              <a:lnSpc>
+                <a:spcPct val="110000"/>
+              </a:lnSpc>
+              <a:spcAft>
+                <a:spcPts val="0"/>
+              </a:spcAft>
+            </a:pPr>
+            <a:r>
+              <a:rPr sz="880" b="0" i="0">
+                <a:solidFill>
+                  <a:srgbClr val="1E2430"/>
+                </a:solidFill>
+                <a:latin typeface="Calibri"/>
+                <a:ea typeface="Calibri"/>
+                <a:cs typeface="Calibri"/>
+              </a:rPr>
+              <a:t>• Kết luận thực nghiệm: Chưa ghi nhận IDBO vượt trội hơn DBO trong phạm vi thử nghiệm. Cơ chế cải tiến không kích hoạt do ngưỡng đa dạng (0.001–0.05) thấp hơn độ phân tán thực tế của đàn rời rạc (~0.25).</a:t>
+            </a:r>
+          </a:p>
+        </p:txBody>
+      </p:sp>
+      <p:sp>
+        <p:nvSpPr>
+          <p:cNvPr id="39" name="TextBox 38"/>
+          <p:cNvSpPr txBox="1"/>
+          <p:nvPr/>
+        </p:nvSpPr>
+        <p:spPr>
+          <a:xfrm>
+            <a:off x="6428232" y="5742431"/>
+            <a:ext cx="5120640" cy="365760"/>
+          </a:xfrm>
+          <a:prstGeom prst="rect">
+            <a:avLst/>
+          </a:prstGeom>
+          <a:noFill/>
+        </p:spPr>
+        <p:txBody>
+          <a:bodyPr wrap="square" anchor="t" lIns="0" rIns="0" tIns="0" bIns="0">
+            <a:spAutoFit/>
+          </a:bodyPr>
+          <a:lstStyle/>
+          <a:p>
+            <a:pPr algn="l">
+              <a:lnSpc>
+                <a:spcPct val="110000"/>
+              </a:lnSpc>
+              <a:spcAft>
+                <a:spcPts val="0"/>
+              </a:spcAft>
+            </a:pPr>
+            <a:r>
+              <a:rPr sz="880" b="0" i="0">
+                <a:solidFill>
+                  <a:srgbClr val="1E2430"/>
+                </a:solidFill>
+                <a:latin typeface="Calibri"/>
+                <a:ea typeface="Calibri"/>
+                <a:cs typeface="Calibri"/>
+              </a:rPr>
+              <a:t>  (Chi tiết paired runs &amp; đối chứng 3 cấu hình lưu tại experiments/ablation_dbo_idbo/README.md)</a:t>
+            </a:r>
+          </a:p>
+        </p:txBody>
+      </p:sp>
+      <p:sp>
+        <p:nvSpPr>
+          <p:cNvPr id="40" name="Rectangle 39"/>
           <p:cNvSpPr/>
           <p:nvPr/>
         </p:nvSpPr>
@@ -17613,7 +17967,7 @@
       </p:sp>
       <p:sp>
         <p:nvSpPr>
-          <p:cNvPr id="33" name="TextBox 32"/>
+          <p:cNvPr id="41" name="TextBox 40"/>
           <p:cNvSpPr txBox="1"/>
           <p:nvPr/>
         </p:nvSpPr>
@@ -17657,7 +18011,7 @@
       </p:sp>
       <p:sp>
         <p:nvSpPr>
-          <p:cNvPr id="34" name="TextBox 33"/>
+          <p:cNvPr id="42" name="TextBox 41"/>
           <p:cNvSpPr txBox="1"/>
           <p:nvPr/>
         </p:nvSpPr>

</xml_diff>

<commit_message>
fix(ablation): add direct diversity telemetry, controlled activation check, and review refinements
</commit_message>
<xml_diff>
--- a/docs/slides/Slide_Bao_Cao_Tuan_8_9_DBO_IDBO.pptx
+++ b/docs/slides/Slide_Bao_Cao_Tuan_8_9_DBO_IDBO.pptx
@@ -17776,7 +17776,7 @@
               </a:spcAft>
             </a:pPr>
             <a:r>
-              <a:rPr sz="880" b="0" i="0">
+              <a:rPr sz="860" b="0" i="0">
                 <a:solidFill>
                   <a:srgbClr val="1E2430"/>
                 </a:solidFill>
@@ -17820,7 +17820,7 @@
               </a:spcAft>
             </a:pPr>
             <a:r>
-              <a:rPr sz="880" b="0" i="0">
+              <a:rPr sz="860" b="0" i="0">
                 <a:solidFill>
                   <a:srgbClr val="1E2430"/>
                 </a:solidFill>
@@ -17864,7 +17864,7 @@
               </a:spcAft>
             </a:pPr>
             <a:r>
-              <a:rPr sz="880" b="0" i="0">
+              <a:rPr sz="860" b="0" i="0">
                 <a:solidFill>
                   <a:srgbClr val="1E2430"/>
                 </a:solidFill>
@@ -17872,7 +17872,7 @@
                 <a:ea typeface="Calibri"/>
                 <a:cs typeface="Calibri"/>
               </a:rPr>
-              <a:t>• Kết luận thực nghiệm: Chưa ghi nhận IDBO vượt trội hơn DBO trong phạm vi thử nghiệm. Cơ chế cải tiến không kích hoạt do ngưỡng đa dạng (0.001–0.05) thấp hơn độ phân tán thực tế của đàn rời rạc (~0.25).</a:t>
+              <a:t>• Kết luận thực nghiệm: Chưa ghi nhận IDBO vượt trội hơn DBO trong 3 cấu hình thử nghiệm do telemetry đo được min_diversity = 0.246 &gt; threshold (0.001–0.05). Thử nghiệm Controlled Activation (threshold=0.5) chứng minh pipeline IDBO kích hoạt bình thường khi điều kiện thỏa mãn.</a:t>
             </a:r>
           </a:p>
         </p:txBody>
@@ -17908,7 +17908,7 @@
               </a:spcAft>
             </a:pPr>
             <a:r>
-              <a:rPr sz="880" b="0" i="0">
+              <a:rPr sz="860" b="0" i="0">
                 <a:solidFill>
                   <a:srgbClr val="1E2430"/>
                 </a:solidFill>
@@ -17916,7 +17916,7 @@
                 <a:ea typeface="Calibri"/>
                 <a:cs typeface="Calibri"/>
               </a:rPr>
-              <a:t>  (Chi tiết paired runs &amp; đối chứng 3 cấu hình lưu tại experiments/ablation_dbo_idbo/README.md)</a:t>
+              <a:t>  (Chi tiết paired runs, controlled activation &amp; telemetry lưu tại experiments/ablation_dbo_idbo/README.md)</a:t>
             </a:r>
           </a:p>
         </p:txBody>

</xml_diff>

<commit_message>
fix(slides): remove repository file paths and present direct empirical evidence
</commit_message>
<xml_diff>
--- a/docs/slides/Slide_Bao_Cao_Tuan_8_9_DBO_IDBO.pptx
+++ b/docs/slides/Slide_Bao_Cao_Tuan_8_9_DBO_IDBO.pptx
@@ -6350,7 +6350,7 @@
                 <a:cs typeface="Calibri"/>
               </a:rPr>
               <a:t>W9-F2: Đối chuẩn Mean Fitness &amp; Độ lệch Calo trên 3 hồ sơ
-• Mean Fitness theo CSV: P1 (90.68), P2 (79.27), P3 (88.09).
+• Mean Fitness thực nghiệm 7 ngày: P1 (90.68), P2 (79.27), P3 (88.09).
 • Sai lệch calo: P1 2.37%, P2 5.59%, P3 1.84%; P2 cần tiếp tục cải thiện.</a:t>
             </a:r>
           </a:p>
@@ -8360,7 +8360,7 @@
                           <a:ea typeface="Calibri"/>
                           <a:cs typeface="Calibri"/>
                         </a:rPr>
-                        <a:t>Module kiểm thử</a:t>
+                        <a:t>Phân hệ chức năng</a:t>
                       </a:r>
                     </a:p>
                   </a:txBody>
@@ -8462,7 +8462,7 @@
                           <a:ea typeface="Calibri"/>
                           <a:cs typeface="Calibri"/>
                         </a:rPr>
-                        <a:t>test_two_tier_solver.py</a:t>
+                        <a:t>Tối ưu 2 tầng (Two-Tier Solver)</a:t>
                       </a:r>
                     </a:p>
                   </a:txBody>
@@ -8564,7 +8564,7 @@
                           <a:ea typeface="Calibri"/>
                           <a:cs typeface="Calibri"/>
                         </a:rPr>
-                        <a:t>test_food_selector.py</a:t>
+                        <a:t>Lọc &amp; Chọn món (Food Selector)</a:t>
                       </a:r>
                     </a:p>
                   </a:txBody>
@@ -8666,7 +8666,7 @@
                           <a:ea typeface="Calibri"/>
                           <a:cs typeface="Calibri"/>
                         </a:rPr>
-                        <a:t>test_diversity_penalty.py</a:t>
+                        <a:t>Chống lặp món (Diversity Penalty)</a:t>
                       </a:r>
                     </a:p>
                   </a:txBody>
@@ -8768,7 +8768,7 @@
                           <a:ea typeface="Calibri"/>
                           <a:cs typeface="Calibri"/>
                         </a:rPr>
-                        <a:t>test_portion_utils.py</a:t>
+                        <a:t>Làm tròn khẩu phần 5g (Portions)</a:t>
                       </a:r>
                     </a:p>
                   </a:txBody>
@@ -8870,7 +8870,7 @@
                           <a:ea typeface="Calibri"/>
                           <a:cs typeface="Calibri"/>
                         </a:rPr>
-                        <a:t>test_experiment_week8.py</a:t>
+                        <a:t>Đối chuẩn giải thuật (Tuần 8)</a:t>
                       </a:r>
                     </a:p>
                   </a:txBody>
@@ -8920,7 +8920,7 @@
                           <a:ea typeface="Calibri"/>
                           <a:cs typeface="Calibri"/>
                         </a:rPr>
-                        <a:t>Pipeline chạy benchmark 10 runs, CSV/PNG Tuần 8</a:t>
+                        <a:t>Quy trình đối chuẩn 10 runs, trích xuất biểu đồ</a:t>
                       </a:r>
                     </a:p>
                   </a:txBody>
@@ -8972,7 +8972,7 @@
                           <a:ea typeface="Calibri"/>
                           <a:cs typeface="Calibri"/>
                         </a:rPr>
-                        <a:t>test_experiment_week9.py</a:t>
+                        <a:t>Kế hoạch 7 ngày đa bệnh lý (Tuần 9)</a:t>
                       </a:r>
                     </a:p>
                   </a:txBody>
@@ -9022,7 +9022,7 @@
                           <a:ea typeface="Calibri"/>
                           <a:cs typeface="Calibri"/>
                         </a:rPr>
-                        <a:t>Pipeline 7 ngày, Carbs proxy minh bạch &amp; Natri P1/P2/P3</a:t>
+                        <a:t>Pipeline 7 ngày, kiểm soát Carbs &amp; Natri theo hồ sơ</a:t>
                       </a:r>
                     </a:p>
                   </a:txBody>
@@ -9074,7 +9074,7 @@
                           <a:ea typeface="Calibri"/>
                           <a:cs typeface="Calibri"/>
                         </a:rPr>
-                        <a:t>Data, Culinary &amp; Constraints</a:t>
+                        <a:t>Dữ liệu &amp; Ràng buộc lâm sàng</a:t>
                       </a:r>
                     </a:p>
                   </a:txBody>
@@ -9176,7 +9176,7 @@
                           <a:ea typeface="Calibri"/>
                           <a:cs typeface="Calibri"/>
                         </a:rPr>
-                        <a:t>Module kế thừa Tuần 1–7</a:t>
+                        <a:t>Module nền tảng (Tuần 1–7)</a:t>
                       </a:r>
                     </a:p>
                   </a:txBody>
@@ -9527,10 +9527,10 @@
                 <a:ea typeface="Calibri"/>
                 <a:cs typeface="Calibri"/>
               </a:rPr>
-              <a:t>• Thiết kế &amp; cài đặt Two-Tier Solver (two_tier_solver.py) và Candidate Pools.
-• Cài đặt module làm tròn khẩu phần 5g (portion_utils.py).
-• Viết kịch bản demo_week8.py, demo_week9.py và tổng hợp slide báo cáo.
-• Đóng góp phần Báo cáo Word Mục 1, 3, 5 Tuần 8.</a:t>
+              <a:t>• Thiết kế &amp; cài đặt bộ giải Two-Tier Solver và các bể ứng viên (Candidate Pools).
+• Cài đặt module làm tròn khẩu phần theo bước 5g thực tế chế biến.
+• Xây dựng kịch bản demo trực quan hóa Tuần 8–9 và tổng hợp slide báo cáo.
+• Phụ trách hoàn thiện Báo cáo tiến độ Tuần 8 (Mục 1, 3, 5).</a:t>
             </a:r>
           </a:p>
         </p:txBody>
@@ -9618,10 +9618,10 @@
                 <a:ea typeface="Calibri"/>
                 <a:cs typeface="Calibri"/>
               </a:rPr>
-              <a:t>• Thiết kế cơ chế phạt lặp món (diversity_penalty.py) cửa sổ trượt 2 ngày.
-• Cài đặt bộ đo lường tỷ lệ món chính độc nhất calculate_unique_main_dish_pct.
-• Đóng góp phần Báo cáo Word Mục 2, 4 Tuần 8 và Mục 2 Tuần 9.
-• Thiết kế thuật toán ánh xạ chỉ mục bọ hung rời rạc.</a:t>
+              <a:t>• Thiết kế cơ chế phạt lặp món (Diversity Penalty) cửa sổ trượt 2 ngày.
+• Xây dựng chỉ số đo lường tỷ lệ món chính độc nhất theo chu kỳ tuần.
+• Thiết kế thuật toán ánh xạ chỉ mục bọ hung rời rạc từ vector liên tục.
+• Phụ trách hoàn thiện Báo cáo tiến độ Tuần 8 (Mục 2, 4) và Tuần 9 (Mục 2).</a:t>
             </a:r>
           </a:p>
         </p:txBody>
@@ -9709,10 +9709,10 @@
                 <a:ea typeface="Calibri"/>
                 <a:cs typeface="Calibri"/>
               </a:rPr>
-              <a:t>• Xây dựng kịch bản thực nghiệm Tuần 9 (experiment_week9.py, 3 profiles).
-• Cài đặt bộ vẽ đồ thị plot_week8.py &amp; plot_week9.py (Heatmap, Radar, Bar chart).
-• Triển khai bộ sinh đa phương án UX generate_options_week9.py (Option A/B/C).
-• Phân tích số liệu và hoàn thiện báo cáo Word Mục 3, 4, 5 Tuần 9.</a:t>
+              <a:t>• Xây dựng kịch bản thực nghiệm Tuần 9 trên 3 hồ sơ bệnh lý mô phỏng.
+• Thiết kế &amp; cài đặt hệ thống biểu đồ trực quan (Heatmap, Radar, Bar chart).
+• Triển khai bộ sinh đa phương án thực đơn tùy biến người dùng (Option A/B/C).
+• Phụ trách phân tích số liệu và hoàn thiện Báo cáo tiến độ Tuần 9 (Mục 3, 4, 5).</a:t>
             </a:r>
           </a:p>
         </p:txBody>
@@ -17754,7 +17754,7 @@
         <p:spPr>
           <a:xfrm>
             <a:off x="6428232" y="4590288"/>
-            <a:ext cx="5120640" cy="365760"/>
+            <a:ext cx="5120640" cy="457200"/>
           </a:xfrm>
           <a:prstGeom prst="rect">
             <a:avLst/>
@@ -17769,14 +17769,14 @@
           <a:p>
             <a:pPr algn="l">
               <a:lnSpc>
-                <a:spcPct val="110000"/>
+                <a:spcPct val="112000"/>
               </a:lnSpc>
               <a:spcAft>
                 <a:spcPts val="0"/>
               </a:spcAft>
             </a:pPr>
             <a:r>
-              <a:rPr sz="860" b="0" i="0">
+              <a:rPr sz="869" b="0" i="0">
                 <a:solidFill>
                   <a:srgbClr val="1E2430"/>
                 </a:solidFill>
@@ -17784,7 +17784,7 @@
                 <a:ea typeface="Calibri"/>
                 <a:cs typeface="Calibri"/>
               </a:rPr>
-              <a:t>• Baseline 25 vòng: DBO Mean 98.2148 | IDBO Mean 98.2148 | Perturbations: 0 | Restarts: 0</a:t>
+              <a:t>• Đối chuẩn 10 seed: Baseline (25 vòng) &amp; Chẩn đoán (100 vòng) đều đạt Mean Fitness 98.21 và 97.98 (0 kích hoạt, hiệu số Δ = 0.00).</a:t>
             </a:r>
           </a:p>
         </p:txBody>
@@ -17797,8 +17797,8 @@
         </p:nvSpPr>
         <p:spPr>
           <a:xfrm>
-            <a:off x="6428232" y="4974336"/>
-            <a:ext cx="5120640" cy="365760"/>
+            <a:off x="6428232" y="5084064"/>
+            <a:ext cx="5120640" cy="457200"/>
           </a:xfrm>
           <a:prstGeom prst="rect">
             <a:avLst/>
@@ -17813,14 +17813,14 @@
           <a:p>
             <a:pPr algn="l">
               <a:lnSpc>
-                <a:spcPct val="110000"/>
+                <a:spcPct val="112000"/>
               </a:lnSpc>
               <a:spcAft>
                 <a:spcPts val="0"/>
               </a:spcAft>
             </a:pPr>
             <a:r>
-              <a:rPr sz="860" b="0" i="0">
+              <a:rPr sz="869" b="0" i="0">
                 <a:solidFill>
                   <a:srgbClr val="1E2430"/>
                 </a:solidFill>
@@ -17828,7 +17828,7 @@
                 <a:ea typeface="Calibri"/>
                 <a:cs typeface="Calibri"/>
               </a:rPr>
-              <a:t>• Chẩn đoán 100 vòng: DBO Mean 97.9821 | IDBO Mean 97.9821 | Perturbations: 0 | Restarts: 0</a:t>
+              <a:t>• Bằng chứng Telemetry trực tiếp: Độ đa dạng quần thể thực tế duy trì ở mức cao min_diversity = 0.246 &gt; threshold (0.001–0.05). Quần thể không bị suy biến nên toán tử giải cứu (perturbation/restart) không bị kích hoạt.</a:t>
             </a:r>
           </a:p>
         </p:txBody>
@@ -17841,8 +17841,8 @@
         </p:nvSpPr>
         <p:spPr>
           <a:xfrm>
-            <a:off x="6428232" y="5358383"/>
-            <a:ext cx="5120640" cy="365760"/>
+            <a:off x="6428232" y="5577840"/>
+            <a:ext cx="5120640" cy="457200"/>
           </a:xfrm>
           <a:prstGeom prst="rect">
             <a:avLst/>
@@ -17857,14 +17857,14 @@
           <a:p>
             <a:pPr algn="l">
               <a:lnSpc>
-                <a:spcPct val="110000"/>
+                <a:spcPct val="112000"/>
               </a:lnSpc>
               <a:spcAft>
                 <a:spcPts val="0"/>
               </a:spcAft>
             </a:pPr>
             <a:r>
-              <a:rPr sz="860" b="0" i="0">
+              <a:rPr sz="869" b="0" i="0">
                 <a:solidFill>
                   <a:srgbClr val="1E2430"/>
                 </a:solidFill>
@@ -17872,58 +17872,14 @@
                 <a:ea typeface="Calibri"/>
                 <a:cs typeface="Calibri"/>
               </a:rPr>
-              <a:t>• Kết luận thực nghiệm: Chưa ghi nhận IDBO vượt trội hơn DBO trong 3 cấu hình thử nghiệm do telemetry đo được min_diversity = 0.246 &gt; threshold (0.001–0.05). Thử nghiệm Controlled Activation (threshold=0.5) chứng minh pipeline IDBO kích hoạt bình thường khi điều kiện thỏa mãn.</a:t>
-            </a:r>
-          </a:p>
-        </p:txBody>
-      </p:sp>
-      <p:sp>
-        <p:nvSpPr>
-          <p:cNvPr id="39" name="TextBox 38"/>
-          <p:cNvSpPr txBox="1"/>
-          <p:nvPr/>
-        </p:nvSpPr>
-        <p:spPr>
-          <a:xfrm>
-            <a:off x="6428232" y="5742431"/>
-            <a:ext cx="5120640" cy="365760"/>
-          </a:xfrm>
-          <a:prstGeom prst="rect">
-            <a:avLst/>
-          </a:prstGeom>
-          <a:noFill/>
-        </p:spPr>
-        <p:txBody>
-          <a:bodyPr wrap="square" anchor="t" lIns="0" rIns="0" tIns="0" bIns="0">
-            <a:spAutoFit/>
-          </a:bodyPr>
-          <a:lstStyle/>
-          <a:p>
-            <a:pPr algn="l">
-              <a:lnSpc>
-                <a:spcPct val="110000"/>
-              </a:lnSpc>
-              <a:spcAft>
-                <a:spcPts val="0"/>
-              </a:spcAft>
-            </a:pPr>
-            <a:r>
-              <a:rPr sz="860" b="0" i="0">
-                <a:solidFill>
-                  <a:srgbClr val="1E2430"/>
-                </a:solidFill>
-                <a:latin typeface="Calibri"/>
-                <a:ea typeface="Calibri"/>
-                <a:cs typeface="Calibri"/>
-              </a:rPr>
-              <a:t>  (Chi tiết paired runs, controlled activation &amp; telemetry lưu tại experiments/ablation_dbo_idbo/README.md)</a:t>
-            </a:r>
-          </a:p>
-        </p:txBody>
-      </p:sp>
-      <p:sp>
-        <p:nvSpPr>
-          <p:cNvPr id="40" name="Rectangle 39"/>
+              <a:t>• Thử nghiệm Controlled Activation (ngưỡng 0.50): IDBO kích hoạt mạnh mẽ 30 lần ở Outer và 8.098 lần ở Inner (Seed 8001) → Khẳng định đường dây và giải thuật IDBO được kết nối hoàn toàn chính xác.</a:t>
+            </a:r>
+          </a:p>
+        </p:txBody>
+      </p:sp>
+      <p:sp>
+        <p:nvSpPr>
+          <p:cNvPr id="39" name="Rectangle 38"/>
           <p:cNvSpPr/>
           <p:nvPr/>
         </p:nvSpPr>
@@ -17967,7 +17923,7 @@
       </p:sp>
       <p:sp>
         <p:nvSpPr>
-          <p:cNvPr id="41" name="TextBox 40"/>
+          <p:cNvPr id="40" name="TextBox 39"/>
           <p:cNvSpPr txBox="1"/>
           <p:nvPr/>
         </p:nvSpPr>
@@ -18011,7 +17967,7 @@
       </p:sp>
       <p:sp>
         <p:nvSpPr>
-          <p:cNvPr id="42" name="TextBox 41"/>
+          <p:cNvPr id="41" name="TextBox 40"/>
           <p:cNvSpPr txBox="1"/>
           <p:nvPr/>
         </p:nvSpPr>
@@ -20036,7 +19992,7 @@
                 <a:ea typeface="Calibri"/>
                 <a:cs typeface="Calibri"/>
               </a:rPr>
-              <a:t>• Đạt chuẩn khẩu phần: Hàm round_portions(x, step=5) loại bỏ hoàn toàn số lẻ thập phân.
+              <a:t>• Đạt chuẩn khẩu phần: Cơ chế làm tròn về bước 5g loại bỏ hoàn toàn số lẻ thập phân, giúp người dùng dễ dàng cân đong khi chế biến.
 • Dinh dưỡng: Protein 122.8g | Carbs 312.4g | Fat 82.1g. Nghiệm chưa áp dụng DishRole và serving bounds theo nhóm; một số tổ hợp chưa phù hợp thực tế ẩm thực.</a:t>
             </a:r>
           </a:p>

</xml_diff>